<commit_message>
Kitchen Table Exercise deck: reworded closing slides
Marc's edits to slides 22-25 and 30: softer wording on what the steps reveal and on hosting, and a new account of where the method came from (testing whether everyone is already an expert systems thinker, at his kitchen table).

Co-Authored-By: Claude Opus 5.5 <noreply@anthropic.com>
</commit_message>
<xml_diff>
--- a/methods/kitchen-table/kitchen-table-exercise.pptx
+++ b/methods/kitchen-table/kitchen-table-exercise.pptx
@@ -5,38 +5,38 @@
     <p:sldMasterId id="2147483648" r:id="rId1"/>
   </p:sldMasterIdLst>
   <p:sldIdLst>
-    <p:sldId id="256" r:id="rId7"/>
-    <p:sldId id="257" r:id="rId8"/>
-    <p:sldId id="258" r:id="rId9"/>
-    <p:sldId id="259" r:id="rId10"/>
-    <p:sldId id="260" r:id="rId11"/>
-    <p:sldId id="261" r:id="rId12"/>
-    <p:sldId id="262" r:id="rId13"/>
-    <p:sldId id="263" r:id="rId14"/>
-    <p:sldId id="264" r:id="rId15"/>
-    <p:sldId id="265" r:id="rId16"/>
-    <p:sldId id="266" r:id="rId17"/>
-    <p:sldId id="267" r:id="rId18"/>
-    <p:sldId id="268" r:id="rId19"/>
-    <p:sldId id="269" r:id="rId20"/>
-    <p:sldId id="270" r:id="rId21"/>
-    <p:sldId id="271" r:id="rId22"/>
-    <p:sldId id="272" r:id="rId23"/>
-    <p:sldId id="273" r:id="rId24"/>
-    <p:sldId id="274" r:id="rId25"/>
-    <p:sldId id="275" r:id="rId26"/>
-    <p:sldId id="276" r:id="rId27"/>
-    <p:sldId id="277" r:id="rId28"/>
-    <p:sldId id="278" r:id="rId29"/>
-    <p:sldId id="279" r:id="rId30"/>
-    <p:sldId id="280" r:id="rId31"/>
-    <p:sldId id="281" r:id="rId32"/>
-    <p:sldId id="282" r:id="rId33"/>
-    <p:sldId id="283" r:id="rId34"/>
-    <p:sldId id="284" r:id="rId35"/>
-    <p:sldId id="285" r:id="rId36"/>
+    <p:sldId id="256" r:id="rId2"/>
+    <p:sldId id="257" r:id="rId3"/>
+    <p:sldId id="258" r:id="rId4"/>
+    <p:sldId id="259" r:id="rId5"/>
+    <p:sldId id="260" r:id="rId6"/>
+    <p:sldId id="261" r:id="rId7"/>
+    <p:sldId id="262" r:id="rId8"/>
+    <p:sldId id="263" r:id="rId9"/>
+    <p:sldId id="264" r:id="rId10"/>
+    <p:sldId id="265" r:id="rId11"/>
+    <p:sldId id="266" r:id="rId12"/>
+    <p:sldId id="267" r:id="rId13"/>
+    <p:sldId id="268" r:id="rId14"/>
+    <p:sldId id="269" r:id="rId15"/>
+    <p:sldId id="270" r:id="rId16"/>
+    <p:sldId id="271" r:id="rId17"/>
+    <p:sldId id="272" r:id="rId18"/>
+    <p:sldId id="273" r:id="rId19"/>
+    <p:sldId id="274" r:id="rId20"/>
+    <p:sldId id="275" r:id="rId21"/>
+    <p:sldId id="276" r:id="rId22"/>
+    <p:sldId id="277" r:id="rId23"/>
+    <p:sldId id="278" r:id="rId24"/>
+    <p:sldId id="279" r:id="rId25"/>
+    <p:sldId id="280" r:id="rId26"/>
+    <p:sldId id="281" r:id="rId27"/>
+    <p:sldId id="282" r:id="rId28"/>
+    <p:sldId id="283" r:id="rId29"/>
+    <p:sldId id="284" r:id="rId30"/>
+    <p:sldId id="285" r:id="rId31"/>
   </p:sldIdLst>
-  <p:sldSz cx="12188952" cy="6858000" type="screen4x3"/>
+  <p:sldSz cx="12188825" cy="6858000"/>
   <p:notesSz cx="6858000" cy="9144000"/>
   <p:defaultTextStyle>
     <a:defPPr>
@@ -133,6 +133,22 @@
       </a:defRPr>
     </a:lvl9pPr>
   </p:defaultTextStyle>
+  <p:extLst>
+    <p:ext uri="{EFAFB233-063F-42B5-8137-9DF3F51BA10A}">
+      <p15:sldGuideLst xmlns:p15="http://schemas.microsoft.com/office/powerpoint/2012/main">
+        <p15:guide id="1" orient="horz" pos="2160">
+          <p15:clr>
+            <a:srgbClr val="A4A3A4"/>
+          </p15:clr>
+        </p15:guide>
+        <p15:guide id="2" pos="2880">
+          <p15:clr>
+            <a:srgbClr val="A4A3A4"/>
+          </p15:clr>
+        </p15:guide>
+      </p15:sldGuideLst>
+    </p:ext>
+  </p:extLst>
 </p:presentation>
 </file>
 
@@ -174,10 +190,9 @@
           <a:lstStyle/>
           <a:p>
             <a:r>
-              <a:rPr lang="en-US" smtClean="0"/>
+              <a:rPr lang="en-US"/>
               <a:t>Click to edit Master title style</a:t>
             </a:r>
-            <a:endParaRPr lang="en-US"/>
           </a:p>
         </p:txBody>
       </p:sp>
@@ -293,10 +308,9 @@
           </a:lstStyle>
           <a:p>
             <a:r>
-              <a:rPr lang="en-US" smtClean="0"/>
+              <a:rPr lang="en-US"/>
               <a:t>Click to edit Master subtitle style</a:t>
             </a:r>
-            <a:endParaRPr lang="en-US"/>
           </a:p>
         </p:txBody>
       </p:sp>
@@ -317,7 +331,7 @@
           <a:p>
             <a:fld id="{5BCAD085-E8A6-8845-BD4E-CB4CCA059FC4}" type="datetimeFigureOut">
               <a:rPr lang="en-US" smtClean="0"/>
-              <a:t>1/27/13</a:t>
+              <a:t>9/24/26</a:t>
             </a:fld>
             <a:endParaRPr lang="en-US"/>
           </a:p>
@@ -411,10 +425,9 @@
           <a:lstStyle/>
           <a:p>
             <a:r>
-              <a:rPr lang="en-US" smtClean="0"/>
+              <a:rPr lang="en-US"/>
               <a:t>Click to edit Master title style</a:t>
             </a:r>
-            <a:endParaRPr lang="en-US"/>
           </a:p>
         </p:txBody>
       </p:sp>
@@ -435,38 +448,37 @@
           <a:p>
             <a:pPr lvl="0"/>
             <a:r>
-              <a:rPr lang="en-US" smtClean="0"/>
+              <a:rPr lang="en-US"/>
               <a:t>Click to edit Master text styles</a:t>
             </a:r>
           </a:p>
           <a:p>
             <a:pPr lvl="1"/>
             <a:r>
-              <a:rPr lang="en-US" smtClean="0"/>
+              <a:rPr lang="en-US"/>
               <a:t>Second level</a:t>
             </a:r>
           </a:p>
           <a:p>
             <a:pPr lvl="2"/>
             <a:r>
-              <a:rPr lang="en-US" smtClean="0"/>
+              <a:rPr lang="en-US"/>
               <a:t>Third level</a:t>
             </a:r>
           </a:p>
           <a:p>
             <a:pPr lvl="3"/>
             <a:r>
-              <a:rPr lang="en-US" smtClean="0"/>
+              <a:rPr lang="en-US"/>
               <a:t>Fourth level</a:t>
             </a:r>
           </a:p>
           <a:p>
             <a:pPr lvl="4"/>
             <a:r>
-              <a:rPr lang="en-US" smtClean="0"/>
+              <a:rPr lang="en-US"/>
               <a:t>Fifth level</a:t>
             </a:r>
-            <a:endParaRPr lang="en-US"/>
           </a:p>
         </p:txBody>
       </p:sp>
@@ -487,7 +499,7 @@
           <a:p>
             <a:fld id="{5BCAD085-E8A6-8845-BD4E-CB4CCA059FC4}" type="datetimeFigureOut">
               <a:rPr lang="en-US" smtClean="0"/>
-              <a:t>1/27/13</a:t>
+              <a:t>9/24/26</a:t>
             </a:fld>
             <a:endParaRPr lang="en-US"/>
           </a:p>
@@ -586,10 +598,9 @@
           <a:lstStyle/>
           <a:p>
             <a:r>
-              <a:rPr lang="en-US" smtClean="0"/>
+              <a:rPr lang="en-US"/>
               <a:t>Click to edit Master title style</a:t>
             </a:r>
-            <a:endParaRPr lang="en-US"/>
           </a:p>
         </p:txBody>
       </p:sp>
@@ -615,38 +626,37 @@
           <a:p>
             <a:pPr lvl="0"/>
             <a:r>
-              <a:rPr lang="en-US" smtClean="0"/>
+              <a:rPr lang="en-US"/>
               <a:t>Click to edit Master text styles</a:t>
             </a:r>
           </a:p>
           <a:p>
             <a:pPr lvl="1"/>
             <a:r>
-              <a:rPr lang="en-US" smtClean="0"/>
+              <a:rPr lang="en-US"/>
               <a:t>Second level</a:t>
             </a:r>
           </a:p>
           <a:p>
             <a:pPr lvl="2"/>
             <a:r>
-              <a:rPr lang="en-US" smtClean="0"/>
+              <a:rPr lang="en-US"/>
               <a:t>Third level</a:t>
             </a:r>
           </a:p>
           <a:p>
             <a:pPr lvl="3"/>
             <a:r>
-              <a:rPr lang="en-US" smtClean="0"/>
+              <a:rPr lang="en-US"/>
               <a:t>Fourth level</a:t>
             </a:r>
           </a:p>
           <a:p>
             <a:pPr lvl="4"/>
             <a:r>
-              <a:rPr lang="en-US" smtClean="0"/>
+              <a:rPr lang="en-US"/>
               <a:t>Fifth level</a:t>
             </a:r>
-            <a:endParaRPr lang="en-US"/>
           </a:p>
         </p:txBody>
       </p:sp>
@@ -667,7 +677,7 @@
           <a:p>
             <a:fld id="{5BCAD085-E8A6-8845-BD4E-CB4CCA059FC4}" type="datetimeFigureOut">
               <a:rPr lang="en-US" smtClean="0"/>
-              <a:t>1/27/13</a:t>
+              <a:t>9/24/26</a:t>
             </a:fld>
             <a:endParaRPr lang="en-US"/>
           </a:p>
@@ -761,10 +771,9 @@
           <a:lstStyle/>
           <a:p>
             <a:r>
-              <a:rPr lang="en-US" smtClean="0"/>
+              <a:rPr lang="en-US"/>
               <a:t>Click to edit Master title style</a:t>
             </a:r>
-            <a:endParaRPr lang="en-US"/>
           </a:p>
         </p:txBody>
       </p:sp>
@@ -785,38 +794,37 @@
           <a:p>
             <a:pPr lvl="0"/>
             <a:r>
-              <a:rPr lang="en-US" smtClean="0"/>
+              <a:rPr lang="en-US"/>
               <a:t>Click to edit Master text styles</a:t>
             </a:r>
           </a:p>
           <a:p>
             <a:pPr lvl="1"/>
             <a:r>
-              <a:rPr lang="en-US" smtClean="0"/>
+              <a:rPr lang="en-US"/>
               <a:t>Second level</a:t>
             </a:r>
           </a:p>
           <a:p>
             <a:pPr lvl="2"/>
             <a:r>
-              <a:rPr lang="en-US" smtClean="0"/>
+              <a:rPr lang="en-US"/>
               <a:t>Third level</a:t>
             </a:r>
           </a:p>
           <a:p>
             <a:pPr lvl="3"/>
             <a:r>
-              <a:rPr lang="en-US" smtClean="0"/>
+              <a:rPr lang="en-US"/>
               <a:t>Fourth level</a:t>
             </a:r>
           </a:p>
           <a:p>
             <a:pPr lvl="4"/>
             <a:r>
-              <a:rPr lang="en-US" smtClean="0"/>
+              <a:rPr lang="en-US"/>
               <a:t>Fifth level</a:t>
             </a:r>
-            <a:endParaRPr lang="en-US"/>
           </a:p>
         </p:txBody>
       </p:sp>
@@ -837,7 +845,7 @@
           <a:p>
             <a:fld id="{5BCAD085-E8A6-8845-BD4E-CB4CCA059FC4}" type="datetimeFigureOut">
               <a:rPr lang="en-US" smtClean="0"/>
-              <a:t>1/27/13</a:t>
+              <a:t>9/24/26</a:t>
             </a:fld>
             <a:endParaRPr lang="en-US"/>
           </a:p>
@@ -940,10 +948,9 @@
           </a:lstStyle>
           <a:p>
             <a:r>
-              <a:rPr lang="en-US" smtClean="0"/>
+              <a:rPr lang="en-US"/>
               <a:t>Click to edit Master title style</a:t>
             </a:r>
-            <a:endParaRPr lang="en-US"/>
           </a:p>
         </p:txBody>
       </p:sp>
@@ -1060,7 +1067,7 @@
           <a:p>
             <a:pPr lvl="0"/>
             <a:r>
-              <a:rPr lang="en-US" smtClean="0"/>
+              <a:rPr lang="en-US"/>
               <a:t>Click to edit Master text styles</a:t>
             </a:r>
           </a:p>
@@ -1083,7 +1090,7 @@
           <a:p>
             <a:fld id="{5BCAD085-E8A6-8845-BD4E-CB4CCA059FC4}" type="datetimeFigureOut">
               <a:rPr lang="en-US" smtClean="0"/>
-              <a:t>1/27/13</a:t>
+              <a:t>9/24/26</a:t>
             </a:fld>
             <a:endParaRPr lang="en-US"/>
           </a:p>
@@ -1177,10 +1184,9 @@
           <a:lstStyle/>
           <a:p>
             <a:r>
-              <a:rPr lang="en-US" smtClean="0"/>
+              <a:rPr lang="en-US"/>
               <a:t>Click to edit Master title style</a:t>
             </a:r>
-            <a:endParaRPr lang="en-US"/>
           </a:p>
         </p:txBody>
       </p:sp>
@@ -1234,38 +1240,37 @@
           <a:p>
             <a:pPr lvl="0"/>
             <a:r>
-              <a:rPr lang="en-US" smtClean="0"/>
+              <a:rPr lang="en-US"/>
               <a:t>Click to edit Master text styles</a:t>
             </a:r>
           </a:p>
           <a:p>
             <a:pPr lvl="1"/>
             <a:r>
-              <a:rPr lang="en-US" smtClean="0"/>
+              <a:rPr lang="en-US"/>
               <a:t>Second level</a:t>
             </a:r>
           </a:p>
           <a:p>
             <a:pPr lvl="2"/>
             <a:r>
-              <a:rPr lang="en-US" smtClean="0"/>
+              <a:rPr lang="en-US"/>
               <a:t>Third level</a:t>
             </a:r>
           </a:p>
           <a:p>
             <a:pPr lvl="3"/>
             <a:r>
-              <a:rPr lang="en-US" smtClean="0"/>
+              <a:rPr lang="en-US"/>
               <a:t>Fourth level</a:t>
             </a:r>
           </a:p>
           <a:p>
             <a:pPr lvl="4"/>
             <a:r>
-              <a:rPr lang="en-US" smtClean="0"/>
+              <a:rPr lang="en-US"/>
               <a:t>Fifth level</a:t>
             </a:r>
-            <a:endParaRPr lang="en-US"/>
           </a:p>
         </p:txBody>
       </p:sp>
@@ -1319,38 +1324,37 @@
           <a:p>
             <a:pPr lvl="0"/>
             <a:r>
-              <a:rPr lang="en-US" smtClean="0"/>
+              <a:rPr lang="en-US"/>
               <a:t>Click to edit Master text styles</a:t>
             </a:r>
           </a:p>
           <a:p>
             <a:pPr lvl="1"/>
             <a:r>
-              <a:rPr lang="en-US" smtClean="0"/>
+              <a:rPr lang="en-US"/>
               <a:t>Second level</a:t>
             </a:r>
           </a:p>
           <a:p>
             <a:pPr lvl="2"/>
             <a:r>
-              <a:rPr lang="en-US" smtClean="0"/>
+              <a:rPr lang="en-US"/>
               <a:t>Third level</a:t>
             </a:r>
           </a:p>
           <a:p>
             <a:pPr lvl="3"/>
             <a:r>
-              <a:rPr lang="en-US" smtClean="0"/>
+              <a:rPr lang="en-US"/>
               <a:t>Fourth level</a:t>
             </a:r>
           </a:p>
           <a:p>
             <a:pPr lvl="4"/>
             <a:r>
-              <a:rPr lang="en-US" smtClean="0"/>
+              <a:rPr lang="en-US"/>
               <a:t>Fifth level</a:t>
             </a:r>
-            <a:endParaRPr lang="en-US"/>
           </a:p>
         </p:txBody>
       </p:sp>
@@ -1371,7 +1375,7 @@
           <a:p>
             <a:fld id="{5BCAD085-E8A6-8845-BD4E-CB4CCA059FC4}" type="datetimeFigureOut">
               <a:rPr lang="en-US" smtClean="0"/>
-              <a:t>1/27/13</a:t>
+              <a:t>9/24/26</a:t>
             </a:fld>
             <a:endParaRPr lang="en-US"/>
           </a:p>
@@ -1469,10 +1473,9 @@
           </a:lstStyle>
           <a:p>
             <a:r>
-              <a:rPr lang="en-US" smtClean="0"/>
+              <a:rPr lang="en-US"/>
               <a:t>Click to edit Master title style</a:t>
             </a:r>
-            <a:endParaRPr lang="en-US"/>
           </a:p>
         </p:txBody>
       </p:sp>
@@ -1535,7 +1538,7 @@
           <a:p>
             <a:pPr lvl="0"/>
             <a:r>
-              <a:rPr lang="en-US" smtClean="0"/>
+              <a:rPr lang="en-US"/>
               <a:t>Click to edit Master text styles</a:t>
             </a:r>
           </a:p>
@@ -1591,38 +1594,37 @@
           <a:p>
             <a:pPr lvl="0"/>
             <a:r>
-              <a:rPr lang="en-US" smtClean="0"/>
+              <a:rPr lang="en-US"/>
               <a:t>Click to edit Master text styles</a:t>
             </a:r>
           </a:p>
           <a:p>
             <a:pPr lvl="1"/>
             <a:r>
-              <a:rPr lang="en-US" smtClean="0"/>
+              <a:rPr lang="en-US"/>
               <a:t>Second level</a:t>
             </a:r>
           </a:p>
           <a:p>
             <a:pPr lvl="2"/>
             <a:r>
-              <a:rPr lang="en-US" smtClean="0"/>
+              <a:rPr lang="en-US"/>
               <a:t>Third level</a:t>
             </a:r>
           </a:p>
           <a:p>
             <a:pPr lvl="3"/>
             <a:r>
-              <a:rPr lang="en-US" smtClean="0"/>
+              <a:rPr lang="en-US"/>
               <a:t>Fourth level</a:t>
             </a:r>
           </a:p>
           <a:p>
             <a:pPr lvl="4"/>
             <a:r>
-              <a:rPr lang="en-US" smtClean="0"/>
+              <a:rPr lang="en-US"/>
               <a:t>Fifth level</a:t>
             </a:r>
-            <a:endParaRPr lang="en-US"/>
           </a:p>
         </p:txBody>
       </p:sp>
@@ -1685,7 +1687,7 @@
           <a:p>
             <a:pPr lvl="0"/>
             <a:r>
-              <a:rPr lang="en-US" smtClean="0"/>
+              <a:rPr lang="en-US"/>
               <a:t>Click to edit Master text styles</a:t>
             </a:r>
           </a:p>
@@ -1741,38 +1743,37 @@
           <a:p>
             <a:pPr lvl="0"/>
             <a:r>
-              <a:rPr lang="en-US" smtClean="0"/>
+              <a:rPr lang="en-US"/>
               <a:t>Click to edit Master text styles</a:t>
             </a:r>
           </a:p>
           <a:p>
             <a:pPr lvl="1"/>
             <a:r>
-              <a:rPr lang="en-US" smtClean="0"/>
+              <a:rPr lang="en-US"/>
               <a:t>Second level</a:t>
             </a:r>
           </a:p>
           <a:p>
             <a:pPr lvl="2"/>
             <a:r>
-              <a:rPr lang="en-US" smtClean="0"/>
+              <a:rPr lang="en-US"/>
               <a:t>Third level</a:t>
             </a:r>
           </a:p>
           <a:p>
             <a:pPr lvl="3"/>
             <a:r>
-              <a:rPr lang="en-US" smtClean="0"/>
+              <a:rPr lang="en-US"/>
               <a:t>Fourth level</a:t>
             </a:r>
           </a:p>
           <a:p>
             <a:pPr lvl="4"/>
             <a:r>
-              <a:rPr lang="en-US" smtClean="0"/>
+              <a:rPr lang="en-US"/>
               <a:t>Fifth level</a:t>
             </a:r>
-            <a:endParaRPr lang="en-US"/>
           </a:p>
         </p:txBody>
       </p:sp>
@@ -1793,7 +1794,7 @@
           <a:p>
             <a:fld id="{5BCAD085-E8A6-8845-BD4E-CB4CCA059FC4}" type="datetimeFigureOut">
               <a:rPr lang="en-US" smtClean="0"/>
-              <a:t>1/27/13</a:t>
+              <a:t>9/24/26</a:t>
             </a:fld>
             <a:endParaRPr lang="en-US"/>
           </a:p>
@@ -1887,10 +1888,9 @@
           <a:lstStyle/>
           <a:p>
             <a:r>
-              <a:rPr lang="en-US" smtClean="0"/>
+              <a:rPr lang="en-US"/>
               <a:t>Click to edit Master title style</a:t>
             </a:r>
-            <a:endParaRPr lang="en-US"/>
           </a:p>
         </p:txBody>
       </p:sp>
@@ -1911,7 +1911,7 @@
           <a:p>
             <a:fld id="{5BCAD085-E8A6-8845-BD4E-CB4CCA059FC4}" type="datetimeFigureOut">
               <a:rPr lang="en-US" smtClean="0"/>
-              <a:t>1/27/13</a:t>
+              <a:t>9/24/26</a:t>
             </a:fld>
             <a:endParaRPr lang="en-US"/>
           </a:p>
@@ -2006,7 +2006,7 @@
           <a:p>
             <a:fld id="{5BCAD085-E8A6-8845-BD4E-CB4CCA059FC4}" type="datetimeFigureOut">
               <a:rPr lang="en-US" smtClean="0"/>
-              <a:t>1/27/13</a:t>
+              <a:t>9/24/26</a:t>
             </a:fld>
             <a:endParaRPr lang="en-US"/>
           </a:p>
@@ -2109,10 +2109,9 @@
           </a:lstStyle>
           <a:p>
             <a:r>
-              <a:rPr lang="en-US" smtClean="0"/>
+              <a:rPr lang="en-US"/>
               <a:t>Click to edit Master title style</a:t>
             </a:r>
-            <a:endParaRPr lang="en-US"/>
           </a:p>
         </p:txBody>
       </p:sp>
@@ -2166,38 +2165,37 @@
           <a:p>
             <a:pPr lvl="0"/>
             <a:r>
-              <a:rPr lang="en-US" smtClean="0"/>
+              <a:rPr lang="en-US"/>
               <a:t>Click to edit Master text styles</a:t>
             </a:r>
           </a:p>
           <a:p>
             <a:pPr lvl="1"/>
             <a:r>
-              <a:rPr lang="en-US" smtClean="0"/>
+              <a:rPr lang="en-US"/>
               <a:t>Second level</a:t>
             </a:r>
           </a:p>
           <a:p>
             <a:pPr lvl="2"/>
             <a:r>
-              <a:rPr lang="en-US" smtClean="0"/>
+              <a:rPr lang="en-US"/>
               <a:t>Third level</a:t>
             </a:r>
           </a:p>
           <a:p>
             <a:pPr lvl="3"/>
             <a:r>
-              <a:rPr lang="en-US" smtClean="0"/>
+              <a:rPr lang="en-US"/>
               <a:t>Fourth level</a:t>
             </a:r>
           </a:p>
           <a:p>
             <a:pPr lvl="4"/>
             <a:r>
-              <a:rPr lang="en-US" smtClean="0"/>
+              <a:rPr lang="en-US"/>
               <a:t>Fifth level</a:t>
             </a:r>
-            <a:endParaRPr lang="en-US"/>
           </a:p>
         </p:txBody>
       </p:sp>
@@ -2260,7 +2258,7 @@
           <a:p>
             <a:pPr lvl="0"/>
             <a:r>
-              <a:rPr lang="en-US" smtClean="0"/>
+              <a:rPr lang="en-US"/>
               <a:t>Click to edit Master text styles</a:t>
             </a:r>
           </a:p>
@@ -2283,7 +2281,7 @@
           <a:p>
             <a:fld id="{5BCAD085-E8A6-8845-BD4E-CB4CCA059FC4}" type="datetimeFigureOut">
               <a:rPr lang="en-US" smtClean="0"/>
-              <a:t>1/27/13</a:t>
+              <a:t>9/24/26</a:t>
             </a:fld>
             <a:endParaRPr lang="en-US"/>
           </a:p>
@@ -2386,10 +2384,9 @@
           </a:lstStyle>
           <a:p>
             <a:r>
-              <a:rPr lang="en-US" smtClean="0"/>
+              <a:rPr lang="en-US"/>
               <a:t>Click to edit Master title style</a:t>
             </a:r>
-            <a:endParaRPr lang="en-US"/>
           </a:p>
         </p:txBody>
       </p:sp>
@@ -2513,7 +2510,7 @@
           <a:p>
             <a:pPr lvl="0"/>
             <a:r>
-              <a:rPr lang="en-US" smtClean="0"/>
+              <a:rPr lang="en-US"/>
               <a:t>Click to edit Master text styles</a:t>
             </a:r>
           </a:p>
@@ -2536,7 +2533,7 @@
           <a:p>
             <a:fld id="{5BCAD085-E8A6-8845-BD4E-CB4CCA059FC4}" type="datetimeFigureOut">
               <a:rPr lang="en-US" smtClean="0"/>
-              <a:t>1/27/13</a:t>
+              <a:t>9/24/26</a:t>
             </a:fld>
             <a:endParaRPr lang="en-US"/>
           </a:p>
@@ -2645,10 +2642,9 @@
           <a:lstStyle/>
           <a:p>
             <a:r>
-              <a:rPr lang="en-US" smtClean="0"/>
+              <a:rPr lang="en-US"/>
               <a:t>Click to edit Master title style</a:t>
             </a:r>
-            <a:endParaRPr lang="en-US"/>
           </a:p>
         </p:txBody>
       </p:sp>
@@ -2679,38 +2675,37 @@
           <a:p>
             <a:pPr lvl="0"/>
             <a:r>
-              <a:rPr lang="en-US" smtClean="0"/>
+              <a:rPr lang="en-US"/>
               <a:t>Click to edit Master text styles</a:t>
             </a:r>
           </a:p>
           <a:p>
             <a:pPr lvl="1"/>
             <a:r>
-              <a:rPr lang="en-US" smtClean="0"/>
+              <a:rPr lang="en-US"/>
               <a:t>Second level</a:t>
             </a:r>
           </a:p>
           <a:p>
             <a:pPr lvl="2"/>
             <a:r>
-              <a:rPr lang="en-US" smtClean="0"/>
+              <a:rPr lang="en-US"/>
               <a:t>Third level</a:t>
             </a:r>
           </a:p>
           <a:p>
             <a:pPr lvl="3"/>
             <a:r>
-              <a:rPr lang="en-US" smtClean="0"/>
+              <a:rPr lang="en-US"/>
               <a:t>Fourth level</a:t>
             </a:r>
           </a:p>
           <a:p>
             <a:pPr lvl="4"/>
             <a:r>
-              <a:rPr lang="en-US" smtClean="0"/>
+              <a:rPr lang="en-US"/>
               <a:t>Fifth level</a:t>
             </a:r>
-            <a:endParaRPr lang="en-US"/>
           </a:p>
         </p:txBody>
       </p:sp>
@@ -2749,7 +2744,7 @@
           <a:p>
             <a:fld id="{5BCAD085-E8A6-8845-BD4E-CB4CCA059FC4}" type="datetimeFigureOut">
               <a:rPr lang="en-US" smtClean="0"/>
-              <a:t>1/27/13</a:t>
+              <a:t>9/24/26</a:t>
             </a:fld>
             <a:endParaRPr lang="en-US"/>
           </a:p>
@@ -3108,7 +3103,7 @@
 </file>
 
 <file path=ppt/slides/slide1.xml><?xml version="1.0" encoding="utf-8"?>
-<p:sld xmlns:a="http://schemas.openxmlformats.org/drawingml/2006/main" xmlns:p="http://schemas.openxmlformats.org/presentationml/2006/main" xmlns:r="http://schemas.openxmlformats.org/officeDocument/2006/relationships">
+<p:sld xmlns:a="http://schemas.openxmlformats.org/drawingml/2006/main" xmlns:r="http://schemas.openxmlformats.org/officeDocument/2006/relationships" xmlns:p="http://schemas.openxmlformats.org/presentationml/2006/main">
   <p:cSld>
     <p:bg>
       <p:bgPr>
@@ -3124,7 +3119,14 @@
         <p:cNvGrpSpPr/>
         <p:nvPr/>
       </p:nvGrpSpPr>
-      <p:grpSpPr/>
+      <p:grpSpPr>
+        <a:xfrm>
+          <a:off x="0" y="0"/>
+          <a:ext cx="0" cy="0"/>
+          <a:chOff x="0" y="0"/>
+          <a:chExt cx="0" cy="0"/>
+        </a:xfrm>
+      </p:grpSpPr>
       <p:sp>
         <p:nvSpPr>
           <p:cNvPr id="2" name="TextBox 1"/>
@@ -3284,6 +3286,7 @@
           <a:lstStyle/>
           <a:p>
             <a:pPr algn="ctr"/>
+            <a:endParaRPr/>
           </a:p>
         </p:txBody>
       </p:sp>
@@ -3374,7 +3377,7 @@
 </file>
 
 <file path=ppt/slides/slide10.xml><?xml version="1.0" encoding="utf-8"?>
-<p:sld xmlns:a="http://schemas.openxmlformats.org/drawingml/2006/main" xmlns:p="http://schemas.openxmlformats.org/presentationml/2006/main" xmlns:r="http://schemas.openxmlformats.org/officeDocument/2006/relationships">
+<p:sld xmlns:a="http://schemas.openxmlformats.org/drawingml/2006/main" xmlns:r="http://schemas.openxmlformats.org/officeDocument/2006/relationships" xmlns:p="http://schemas.openxmlformats.org/presentationml/2006/main">
   <p:cSld>
     <p:bg>
       <p:bgPr>
@@ -3390,7 +3393,14 @@
         <p:cNvGrpSpPr/>
         <p:nvPr/>
       </p:nvGrpSpPr>
-      <p:grpSpPr/>
+      <p:grpSpPr>
+        <a:xfrm>
+          <a:off x="0" y="0"/>
+          <a:ext cx="0" cy="0"/>
+          <a:chOff x="0" y="0"/>
+          <a:chExt cx="0" cy="0"/>
+        </a:xfrm>
+      </p:grpSpPr>
       <p:sp>
         <p:nvSpPr>
           <p:cNvPr id="2" name="TextBox 1"/>
@@ -3635,7 +3645,7 @@
 </file>
 
 <file path=ppt/slides/slide11.xml><?xml version="1.0" encoding="utf-8"?>
-<p:sld xmlns:a="http://schemas.openxmlformats.org/drawingml/2006/main" xmlns:p="http://schemas.openxmlformats.org/presentationml/2006/main" xmlns:r="http://schemas.openxmlformats.org/officeDocument/2006/relationships">
+<p:sld xmlns:a="http://schemas.openxmlformats.org/drawingml/2006/main" xmlns:r="http://schemas.openxmlformats.org/officeDocument/2006/relationships" xmlns:p="http://schemas.openxmlformats.org/presentationml/2006/main">
   <p:cSld>
     <p:bg>
       <p:bgPr>
@@ -3651,7 +3661,14 @@
         <p:cNvGrpSpPr/>
         <p:nvPr/>
       </p:nvGrpSpPr>
-      <p:grpSpPr/>
+      <p:grpSpPr>
+        <a:xfrm>
+          <a:off x="0" y="0"/>
+          <a:ext cx="0" cy="0"/>
+          <a:chOff x="0" y="0"/>
+          <a:chExt cx="0" cy="0"/>
+        </a:xfrm>
+      </p:grpSpPr>
       <p:sp>
         <p:nvSpPr>
           <p:cNvPr id="2" name="TextBox 1"/>
@@ -3895,7 +3912,7 @@
 </file>
 
 <file path=ppt/slides/slide12.xml><?xml version="1.0" encoding="utf-8"?>
-<p:sld xmlns:a="http://schemas.openxmlformats.org/drawingml/2006/main" xmlns:p="http://schemas.openxmlformats.org/presentationml/2006/main" xmlns:r="http://schemas.openxmlformats.org/officeDocument/2006/relationships">
+<p:sld xmlns:a="http://schemas.openxmlformats.org/drawingml/2006/main" xmlns:r="http://schemas.openxmlformats.org/officeDocument/2006/relationships" xmlns:p="http://schemas.openxmlformats.org/presentationml/2006/main">
   <p:cSld>
     <p:bg>
       <p:bgPr>
@@ -3911,7 +3928,14 @@
         <p:cNvGrpSpPr/>
         <p:nvPr/>
       </p:nvGrpSpPr>
-      <p:grpSpPr/>
+      <p:grpSpPr>
+        <a:xfrm>
+          <a:off x="0" y="0"/>
+          <a:ext cx="0" cy="0"/>
+          <a:chOff x="0" y="0"/>
+          <a:chExt cx="0" cy="0"/>
+        </a:xfrm>
+      </p:grpSpPr>
       <p:sp>
         <p:nvSpPr>
           <p:cNvPr id="2" name="TextBox 1"/>
@@ -4116,7 +4140,7 @@
 </file>
 
 <file path=ppt/slides/slide13.xml><?xml version="1.0" encoding="utf-8"?>
-<p:sld xmlns:a="http://schemas.openxmlformats.org/drawingml/2006/main" xmlns:p="http://schemas.openxmlformats.org/presentationml/2006/main" xmlns:r="http://schemas.openxmlformats.org/officeDocument/2006/relationships">
+<p:sld xmlns:a="http://schemas.openxmlformats.org/drawingml/2006/main" xmlns:r="http://schemas.openxmlformats.org/officeDocument/2006/relationships" xmlns:p="http://schemas.openxmlformats.org/presentationml/2006/main">
   <p:cSld>
     <p:bg>
       <p:bgPr>
@@ -4132,7 +4156,14 @@
         <p:cNvGrpSpPr/>
         <p:nvPr/>
       </p:nvGrpSpPr>
-      <p:grpSpPr/>
+      <p:grpSpPr>
+        <a:xfrm>
+          <a:off x="0" y="0"/>
+          <a:ext cx="0" cy="0"/>
+          <a:chOff x="0" y="0"/>
+          <a:chExt cx="0" cy="0"/>
+        </a:xfrm>
+      </p:grpSpPr>
       <p:sp>
         <p:nvSpPr>
           <p:cNvPr id="2" name="TextBox 1"/>
@@ -4376,7 +4407,7 @@
 </file>
 
 <file path=ppt/slides/slide14.xml><?xml version="1.0" encoding="utf-8"?>
-<p:sld xmlns:a="http://schemas.openxmlformats.org/drawingml/2006/main" xmlns:p="http://schemas.openxmlformats.org/presentationml/2006/main" xmlns:r="http://schemas.openxmlformats.org/officeDocument/2006/relationships">
+<p:sld xmlns:a="http://schemas.openxmlformats.org/drawingml/2006/main" xmlns:r="http://schemas.openxmlformats.org/officeDocument/2006/relationships" xmlns:p="http://schemas.openxmlformats.org/presentationml/2006/main">
   <p:cSld>
     <p:bg>
       <p:bgPr>
@@ -4392,7 +4423,14 @@
         <p:cNvGrpSpPr/>
         <p:nvPr/>
       </p:nvGrpSpPr>
-      <p:grpSpPr/>
+      <p:grpSpPr>
+        <a:xfrm>
+          <a:off x="0" y="0"/>
+          <a:ext cx="0" cy="0"/>
+          <a:chOff x="0" y="0"/>
+          <a:chExt cx="0" cy="0"/>
+        </a:xfrm>
+      </p:grpSpPr>
       <p:sp>
         <p:nvSpPr>
           <p:cNvPr id="2" name="TextBox 1"/>
@@ -4638,7 +4676,7 @@
 </file>
 
 <file path=ppt/slides/slide15.xml><?xml version="1.0" encoding="utf-8"?>
-<p:sld xmlns:a="http://schemas.openxmlformats.org/drawingml/2006/main" xmlns:p="http://schemas.openxmlformats.org/presentationml/2006/main" xmlns:r="http://schemas.openxmlformats.org/officeDocument/2006/relationships">
+<p:sld xmlns:a="http://schemas.openxmlformats.org/drawingml/2006/main" xmlns:r="http://schemas.openxmlformats.org/officeDocument/2006/relationships" xmlns:p="http://schemas.openxmlformats.org/presentationml/2006/main">
   <p:cSld>
     <p:bg>
       <p:bgPr>
@@ -4654,7 +4692,14 @@
         <p:cNvGrpSpPr/>
         <p:nvPr/>
       </p:nvGrpSpPr>
-      <p:grpSpPr/>
+      <p:grpSpPr>
+        <a:xfrm>
+          <a:off x="0" y="0"/>
+          <a:ext cx="0" cy="0"/>
+          <a:chOff x="0" y="0"/>
+          <a:chExt cx="0" cy="0"/>
+        </a:xfrm>
+      </p:grpSpPr>
       <p:sp>
         <p:nvSpPr>
           <p:cNvPr id="2" name="TextBox 1"/>
@@ -4898,7 +4943,7 @@
 </file>
 
 <file path=ppt/slides/slide16.xml><?xml version="1.0" encoding="utf-8"?>
-<p:sld xmlns:a="http://schemas.openxmlformats.org/drawingml/2006/main" xmlns:p="http://schemas.openxmlformats.org/presentationml/2006/main" xmlns:r="http://schemas.openxmlformats.org/officeDocument/2006/relationships">
+<p:sld xmlns:a="http://schemas.openxmlformats.org/drawingml/2006/main" xmlns:r="http://schemas.openxmlformats.org/officeDocument/2006/relationships" xmlns:p="http://schemas.openxmlformats.org/presentationml/2006/main">
   <p:cSld>
     <p:bg>
       <p:bgPr>
@@ -4914,7 +4959,14 @@
         <p:cNvGrpSpPr/>
         <p:nvPr/>
       </p:nvGrpSpPr>
-      <p:grpSpPr/>
+      <p:grpSpPr>
+        <a:xfrm>
+          <a:off x="0" y="0"/>
+          <a:ext cx="0" cy="0"/>
+          <a:chOff x="0" y="0"/>
+          <a:chExt cx="0" cy="0"/>
+        </a:xfrm>
+      </p:grpSpPr>
       <p:sp>
         <p:nvSpPr>
           <p:cNvPr id="2" name="TextBox 1"/>
@@ -5114,6 +5166,7 @@
           <a:lstStyle/>
           <a:p>
             <a:pPr algn="ctr"/>
+            <a:endParaRPr/>
           </a:p>
         </p:txBody>
       </p:sp>
@@ -5243,7 +5296,7 @@
 </file>
 
 <file path=ppt/slides/slide17.xml><?xml version="1.0" encoding="utf-8"?>
-<p:sld xmlns:a="http://schemas.openxmlformats.org/drawingml/2006/main" xmlns:p="http://schemas.openxmlformats.org/presentationml/2006/main" xmlns:r="http://schemas.openxmlformats.org/officeDocument/2006/relationships">
+<p:sld xmlns:a="http://schemas.openxmlformats.org/drawingml/2006/main" xmlns:r="http://schemas.openxmlformats.org/officeDocument/2006/relationships" xmlns:p="http://schemas.openxmlformats.org/presentationml/2006/main">
   <p:cSld>
     <p:bg>
       <p:bgPr>
@@ -5259,7 +5312,14 @@
         <p:cNvGrpSpPr/>
         <p:nvPr/>
       </p:nvGrpSpPr>
-      <p:grpSpPr/>
+      <p:grpSpPr>
+        <a:xfrm>
+          <a:off x="0" y="0"/>
+          <a:ext cx="0" cy="0"/>
+          <a:chOff x="0" y="0"/>
+          <a:chExt cx="0" cy="0"/>
+        </a:xfrm>
+      </p:grpSpPr>
       <p:sp>
         <p:nvSpPr>
           <p:cNvPr id="2" name="TextBox 1"/>
@@ -5506,7 +5566,7 @@
 </file>
 
 <file path=ppt/slides/slide18.xml><?xml version="1.0" encoding="utf-8"?>
-<p:sld xmlns:a="http://schemas.openxmlformats.org/drawingml/2006/main" xmlns:p="http://schemas.openxmlformats.org/presentationml/2006/main" xmlns:r="http://schemas.openxmlformats.org/officeDocument/2006/relationships">
+<p:sld xmlns:a="http://schemas.openxmlformats.org/drawingml/2006/main" xmlns:r="http://schemas.openxmlformats.org/officeDocument/2006/relationships" xmlns:p="http://schemas.openxmlformats.org/presentationml/2006/main">
   <p:cSld>
     <p:bg>
       <p:bgPr>
@@ -5522,7 +5582,14 @@
         <p:cNvGrpSpPr/>
         <p:nvPr/>
       </p:nvGrpSpPr>
-      <p:grpSpPr/>
+      <p:grpSpPr>
+        <a:xfrm>
+          <a:off x="0" y="0"/>
+          <a:ext cx="0" cy="0"/>
+          <a:chOff x="0" y="0"/>
+          <a:chExt cx="0" cy="0"/>
+        </a:xfrm>
+      </p:grpSpPr>
       <p:sp>
         <p:nvSpPr>
           <p:cNvPr id="2" name="TextBox 1"/>
@@ -5727,7 +5794,7 @@
 </file>
 
 <file path=ppt/slides/slide19.xml><?xml version="1.0" encoding="utf-8"?>
-<p:sld xmlns:a="http://schemas.openxmlformats.org/drawingml/2006/main" xmlns:p="http://schemas.openxmlformats.org/presentationml/2006/main" xmlns:r="http://schemas.openxmlformats.org/officeDocument/2006/relationships">
+<p:sld xmlns:a="http://schemas.openxmlformats.org/drawingml/2006/main" xmlns:r="http://schemas.openxmlformats.org/officeDocument/2006/relationships" xmlns:p="http://schemas.openxmlformats.org/presentationml/2006/main">
   <p:cSld>
     <p:bg>
       <p:bgPr>
@@ -5743,7 +5810,14 @@
         <p:cNvGrpSpPr/>
         <p:nvPr/>
       </p:nvGrpSpPr>
-      <p:grpSpPr/>
+      <p:grpSpPr>
+        <a:xfrm>
+          <a:off x="0" y="0"/>
+          <a:ext cx="0" cy="0"/>
+          <a:chOff x="0" y="0"/>
+          <a:chExt cx="0" cy="0"/>
+        </a:xfrm>
+      </p:grpSpPr>
       <p:sp>
         <p:nvSpPr>
           <p:cNvPr id="2" name="TextBox 1"/>
@@ -5904,6 +5978,7 @@
           <a:lstStyle/>
           <a:p>
             <a:pPr algn="ctr"/>
+            <a:endParaRPr/>
           </a:p>
         </p:txBody>
       </p:sp>
@@ -6028,6 +6103,7 @@
           <a:lstStyle/>
           <a:p>
             <a:pPr algn="ctr"/>
+            <a:endParaRPr/>
           </a:p>
         </p:txBody>
       </p:sp>
@@ -6191,6 +6267,7 @@
           <a:lstStyle/>
           <a:p>
             <a:pPr algn="ctr"/>
+            <a:endParaRPr/>
           </a:p>
         </p:txBody>
       </p:sp>
@@ -6354,6 +6431,7 @@
           <a:lstStyle/>
           <a:p>
             <a:pPr algn="ctr"/>
+            <a:endParaRPr/>
           </a:p>
         </p:txBody>
       </p:sp>
@@ -6517,6 +6595,7 @@
           <a:lstStyle/>
           <a:p>
             <a:pPr algn="ctr"/>
+            <a:endParaRPr/>
           </a:p>
         </p:txBody>
       </p:sp>
@@ -6680,6 +6759,7 @@
           <a:lstStyle/>
           <a:p>
             <a:pPr algn="ctr"/>
+            <a:endParaRPr/>
           </a:p>
         </p:txBody>
       </p:sp>
@@ -6843,6 +6923,7 @@
           <a:lstStyle/>
           <a:p>
             <a:pPr algn="ctr"/>
+            <a:endParaRPr/>
           </a:p>
         </p:txBody>
       </p:sp>
@@ -7006,6 +7087,7 @@
           <a:lstStyle/>
           <a:p>
             <a:pPr algn="ctr"/>
+            <a:endParaRPr/>
           </a:p>
         </p:txBody>
       </p:sp>
@@ -7169,6 +7251,7 @@
           <a:lstStyle/>
           <a:p>
             <a:pPr algn="ctr"/>
+            <a:endParaRPr/>
           </a:p>
         </p:txBody>
       </p:sp>
@@ -7293,6 +7376,7 @@
           <a:lstStyle/>
           <a:p>
             <a:pPr algn="ctr"/>
+            <a:endParaRPr/>
           </a:p>
         </p:txBody>
       </p:sp>
@@ -7305,7 +7389,7 @@
         <p:spPr>
           <a:xfrm>
             <a:off x="1051560" y="5650992"/>
-            <a:ext cx="10058400" cy="457200"/>
+            <a:ext cx="10058400" cy="556178"/>
           </a:xfrm>
           <a:prstGeom prst="rect">
             <a:avLst/>
@@ -7324,7 +7408,7 @@
               </a:lnSpc>
             </a:pPr>
             <a:r>
-              <a:rPr sz="1350" b="1" i="0">
+              <a:rPr sz="1350" b="1" i="0" dirty="0">
                 <a:solidFill>
                   <a:srgbClr val="3D5A6C"/>
                 </a:solidFill>
@@ -7332,6 +7416,21 @@
               </a:rPr>
               <a:t>Every one of these is something you were already doing before anybody taught you anything. The exercise did not install a skill. It named one you had.</a:t>
             </a:r>
+            <a:r>
+              <a:rPr lang="en-US" sz="1350" b="1" i="0" dirty="0">
+                <a:solidFill>
+                  <a:srgbClr val="3D5A6C"/>
+                </a:solidFill>
+                <a:latin typeface="Calibri"/>
+              </a:rPr>
+              <a:t> AND it connected your skills into a much more powerful skill.</a:t>
+            </a:r>
+            <a:endParaRPr sz="1350" b="1" i="0" dirty="0">
+              <a:solidFill>
+                <a:srgbClr val="3D5A6C"/>
+              </a:solidFill>
+              <a:latin typeface="Calibri"/>
+            </a:endParaRPr>
           </a:p>
         </p:txBody>
       </p:sp>
@@ -7363,7 +7462,7 @@
               </a:lnSpc>
             </a:pPr>
             <a:r>
-              <a:rPr sz="900" b="0" i="0">
+              <a:rPr sz="900" b="0" i="0" dirty="0">
                 <a:solidFill>
                   <a:srgbClr val="918C82"/>
                 </a:solidFill>
@@ -7422,7 +7521,7 @@
 </file>
 
 <file path=ppt/slides/slide2.xml><?xml version="1.0" encoding="utf-8"?>
-<p:sld xmlns:a="http://schemas.openxmlformats.org/drawingml/2006/main" xmlns:p="http://schemas.openxmlformats.org/presentationml/2006/main" xmlns:r="http://schemas.openxmlformats.org/officeDocument/2006/relationships">
+<p:sld xmlns:a="http://schemas.openxmlformats.org/drawingml/2006/main" xmlns:r="http://schemas.openxmlformats.org/officeDocument/2006/relationships" xmlns:p="http://schemas.openxmlformats.org/presentationml/2006/main">
   <p:cSld>
     <p:bg>
       <p:bgPr>
@@ -7438,7 +7537,14 @@
         <p:cNvGrpSpPr/>
         <p:nvPr/>
       </p:nvGrpSpPr>
-      <p:grpSpPr/>
+      <p:grpSpPr>
+        <a:xfrm>
+          <a:off x="0" y="0"/>
+          <a:ext cx="0" cy="0"/>
+          <a:chOff x="0" y="0"/>
+          <a:chExt cx="0" cy="0"/>
+        </a:xfrm>
+      </p:grpSpPr>
       <p:sp>
         <p:nvSpPr>
           <p:cNvPr id="2" name="TextBox 1"/>
@@ -7660,6 +7766,7 @@
           <a:lstStyle/>
           <a:p>
             <a:pPr algn="ctr"/>
+            <a:endParaRPr/>
           </a:p>
         </p:txBody>
       </p:sp>
@@ -7789,7 +7896,7 @@
 </file>
 
 <file path=ppt/slides/slide20.xml><?xml version="1.0" encoding="utf-8"?>
-<p:sld xmlns:a="http://schemas.openxmlformats.org/drawingml/2006/main" xmlns:p="http://schemas.openxmlformats.org/presentationml/2006/main" xmlns:r="http://schemas.openxmlformats.org/officeDocument/2006/relationships">
+<p:sld xmlns:a="http://schemas.openxmlformats.org/drawingml/2006/main" xmlns:r="http://schemas.openxmlformats.org/officeDocument/2006/relationships" xmlns:p="http://schemas.openxmlformats.org/presentationml/2006/main">
   <p:cSld>
     <p:bg>
       <p:bgPr>
@@ -7805,7 +7912,14 @@
         <p:cNvGrpSpPr/>
         <p:nvPr/>
       </p:nvGrpSpPr>
-      <p:grpSpPr/>
+      <p:grpSpPr>
+        <a:xfrm>
+          <a:off x="0" y="0"/>
+          <a:ext cx="0" cy="0"/>
+          <a:chOff x="0" y="0"/>
+          <a:chExt cx="0" cy="0"/>
+        </a:xfrm>
+      </p:grpSpPr>
       <p:sp>
         <p:nvSpPr>
           <p:cNvPr id="2" name="TextBox 1"/>
@@ -8003,6 +8117,7 @@
           <a:lstStyle/>
           <a:p>
             <a:pPr algn="ctr"/>
+            <a:endParaRPr/>
           </a:p>
         </p:txBody>
       </p:sp>
@@ -8132,7 +8247,7 @@
 </file>
 
 <file path=ppt/slides/slide21.xml><?xml version="1.0" encoding="utf-8"?>
-<p:sld xmlns:a="http://schemas.openxmlformats.org/drawingml/2006/main" xmlns:p="http://schemas.openxmlformats.org/presentationml/2006/main" xmlns:r="http://schemas.openxmlformats.org/officeDocument/2006/relationships">
+<p:sld xmlns:a="http://schemas.openxmlformats.org/drawingml/2006/main" xmlns:r="http://schemas.openxmlformats.org/officeDocument/2006/relationships" xmlns:p="http://schemas.openxmlformats.org/presentationml/2006/main">
   <p:cSld>
     <p:bg>
       <p:bgPr>
@@ -8148,7 +8263,14 @@
         <p:cNvGrpSpPr/>
         <p:nvPr/>
       </p:nvGrpSpPr>
-      <p:grpSpPr/>
+      <p:grpSpPr>
+        <a:xfrm>
+          <a:off x="0" y="0"/>
+          <a:ext cx="0" cy="0"/>
+          <a:chOff x="0" y="0"/>
+          <a:chExt cx="0" cy="0"/>
+        </a:xfrm>
+      </p:grpSpPr>
       <p:sp>
         <p:nvSpPr>
           <p:cNvPr id="2" name="TextBox 1"/>
@@ -8270,6 +8392,7 @@
           <a:lstStyle/>
           <a:p>
             <a:pPr algn="ctr"/>
+            <a:endParaRPr/>
           </a:p>
         </p:txBody>
       </p:sp>
@@ -8321,7 +8444,7 @@
         <p:spPr>
           <a:xfrm>
             <a:off x="777240" y="3154680"/>
-            <a:ext cx="10332720" cy="822960"/>
+            <a:ext cx="10332720" cy="492122"/>
           </a:xfrm>
           <a:prstGeom prst="rect">
             <a:avLst/>
@@ -8340,13 +8463,49 @@
               </a:lnSpc>
             </a:pPr>
             <a:r>
-              <a:rPr sz="2400" b="1" i="0">
+              <a:rPr lang="en-US" sz="2400" b="1" dirty="0">
                 <a:solidFill>
                   <a:srgbClr val="14130F"/>
                 </a:solidFill>
                 <a:latin typeface="Calibri"/>
               </a:rPr>
-              <a:t>The difficulty does not fall evenly. It concentrates wherever nobody is telling you whether you are right.</a:t>
+              <a:t>Felt d</a:t>
+            </a:r>
+            <a:r>
+              <a:rPr sz="2400" b="1" i="0" dirty="0">
+                <a:solidFill>
+                  <a:srgbClr val="14130F"/>
+                </a:solidFill>
+                <a:latin typeface="Calibri"/>
+              </a:rPr>
+              <a:t>ifficulty </a:t>
+            </a:r>
+            <a:r>
+              <a:rPr lang="en-US" sz="2400" b="1" i="0" dirty="0">
+                <a:solidFill>
+                  <a:srgbClr val="14130F"/>
+                </a:solidFill>
+                <a:latin typeface="Calibri"/>
+              </a:rPr>
+              <a:t>may arise when there </a:t>
+            </a:r>
+            <a:r>
+              <a:rPr lang="en-US" sz="2400" b="1" dirty="0">
+                <a:solidFill>
+                  <a:srgbClr val="14130F"/>
+                </a:solidFill>
+                <a:latin typeface="Calibri"/>
+              </a:rPr>
+              <a:t>are no standards for your performance</a:t>
+            </a:r>
+            <a:r>
+              <a:rPr sz="2400" b="1" i="0" dirty="0">
+                <a:solidFill>
+                  <a:srgbClr val="14130F"/>
+                </a:solidFill>
+                <a:latin typeface="Calibri"/>
+              </a:rPr>
+              <a:t>.</a:t>
             </a:r>
           </a:p>
         </p:txBody>
@@ -8359,8 +8518,8 @@
         </p:nvSpPr>
         <p:spPr>
           <a:xfrm>
-            <a:off x="777240" y="4114800"/>
-            <a:ext cx="10332720" cy="2011680"/>
+            <a:off x="777240" y="4136316"/>
+            <a:ext cx="10332720" cy="1905137"/>
           </a:xfrm>
           <a:prstGeom prst="rect">
             <a:avLst/>
@@ -8382,13 +8541,31 @@
               </a:spcAft>
             </a:pPr>
             <a:r>
-              <a:rPr sz="1550" b="0">
+              <a:rPr sz="1550" b="0" dirty="0">
                 <a:solidFill>
                   <a:srgbClr val="4A4740"/>
                 </a:solidFill>
                 <a:latin typeface="Calibri"/>
               </a:rPr>
-              <a:t>—  Most of us learned to work in places where somebody else says whether it counts.</a:t>
+              <a:t>—  Most of us learned to work in places where somebody else says </a:t>
+            </a:r>
+            <a:r>
+              <a:rPr lang="en-US" sz="1550" b="0" dirty="0">
+                <a:solidFill>
+                  <a:srgbClr val="4A4740"/>
+                </a:solidFill>
+                <a:latin typeface="Calibri"/>
+              </a:rPr>
+              <a:t>what</a:t>
+            </a:r>
+            <a:r>
+              <a:rPr sz="1550" b="0" dirty="0">
+                <a:solidFill>
+                  <a:srgbClr val="4A4740"/>
+                </a:solidFill>
+                <a:latin typeface="Calibri"/>
+              </a:rPr>
+              <a:t> it counts.</a:t>
             </a:r>
           </a:p>
           <a:p>
@@ -8401,13 +8578,67 @@
               </a:spcAft>
             </a:pPr>
             <a:r>
-              <a:rPr sz="1550" b="0">
+              <a:rPr sz="1550" b="0" dirty="0">
                 <a:solidFill>
                   <a:srgbClr val="4A4740"/>
                 </a:solidFill>
                 <a:latin typeface="Calibri"/>
               </a:rPr>
-              <a:t>—  This exercise removes that at every single step, and what people feel is the removal.</a:t>
+              <a:t>—  This exercise </a:t>
+            </a:r>
+            <a:r>
+              <a:rPr lang="en-US" sz="1550" b="0" dirty="0">
+                <a:solidFill>
+                  <a:srgbClr val="4A4740"/>
+                </a:solidFill>
+                <a:latin typeface="Calibri"/>
+              </a:rPr>
+              <a:t>attempts to </a:t>
+            </a:r>
+            <a:r>
+              <a:rPr sz="1550" b="0" dirty="0">
+                <a:solidFill>
+                  <a:srgbClr val="4A4740"/>
+                </a:solidFill>
+                <a:latin typeface="Calibri"/>
+              </a:rPr>
+              <a:t>remove that at </a:t>
+            </a:r>
+            <a:r>
+              <a:rPr lang="en-US" sz="1550" b="0" dirty="0">
+                <a:solidFill>
+                  <a:srgbClr val="4A4740"/>
+                </a:solidFill>
+                <a:latin typeface="Calibri"/>
+              </a:rPr>
+              <a:t>each </a:t>
+            </a:r>
+            <a:r>
+              <a:rPr sz="1550" b="0" dirty="0">
+                <a:solidFill>
+                  <a:srgbClr val="4A4740"/>
+                </a:solidFill>
+                <a:latin typeface="Calibri"/>
+              </a:rPr>
+              <a:t>step</a:t>
+            </a:r>
+            <a:r>
+              <a:rPr lang="en-US" sz="1550" b="0" dirty="0">
+                <a:solidFill>
+                  <a:srgbClr val="4A4740"/>
+                </a:solidFill>
+                <a:latin typeface="Calibri"/>
+              </a:rPr>
+              <a:t>. The absence produce some discomfort</a:t>
+            </a:r>
+            <a:r>
+              <a:rPr sz="1550" b="0" dirty="0">
+                <a:solidFill>
+                  <a:srgbClr val="4A4740"/>
+                </a:solidFill>
+                <a:latin typeface="Calibri"/>
+              </a:rPr>
+              <a:t>.</a:t>
             </a:r>
           </a:p>
           <a:p>
@@ -8420,13 +8651,67 @@
               </a:spcAft>
             </a:pPr>
             <a:r>
-              <a:rPr sz="1550" b="0">
+              <a:rPr sz="1550" b="0" dirty="0">
                 <a:solidFill>
                   <a:srgbClr val="4A4740"/>
                 </a:solidFill>
                 <a:latin typeface="Calibri"/>
               </a:rPr>
-              <a:t>—  The useful sentence is not "I am bad at this". It is "I was trained to need something that is not in this room".</a:t>
+              <a:t>— </a:t>
+            </a:r>
+            <a:r>
+              <a:rPr lang="en-US" sz="1550" b="0" dirty="0">
+                <a:solidFill>
+                  <a:srgbClr val="4A4740"/>
+                </a:solidFill>
+                <a:latin typeface="Calibri"/>
+              </a:rPr>
+              <a:t>No one is </a:t>
+            </a:r>
+            <a:r>
+              <a:rPr sz="1550" b="0" dirty="0">
+                <a:solidFill>
+                  <a:srgbClr val="4A4740"/>
+                </a:solidFill>
+                <a:latin typeface="Calibri"/>
+              </a:rPr>
+              <a:t>" bad at this". </a:t>
+            </a:r>
+            <a:r>
+              <a:rPr lang="en-US" sz="1550" dirty="0">
+                <a:solidFill>
+                  <a:srgbClr val="4A4740"/>
+                </a:solidFill>
+                <a:latin typeface="Calibri"/>
+              </a:rPr>
+              <a:t>Most of us have been conditioned to “paint within the lines."</a:t>
+            </a:r>
+            <a:r>
+              <a:rPr sz="1550" b="0" dirty="0">
+                <a:solidFill>
+                  <a:srgbClr val="4A4740"/>
+                </a:solidFill>
+                <a:latin typeface="Calibri"/>
+              </a:rPr>
+              <a:t> </a:t>
+            </a:r>
+            <a:r>
+              <a:rPr lang="en-US" sz="1550" b="0" dirty="0">
+                <a:solidFill>
+                  <a:srgbClr val="4A4740"/>
+                </a:solidFill>
+                <a:latin typeface="Calibri"/>
+              </a:rPr>
+              <a:t>Sometimes that can be useful. This is not one of those times.</a:t>
+            </a:r>
+            <a:r>
+              <a:rPr sz="1550" b="0" dirty="0">
+                <a:solidFill>
+                  <a:srgbClr val="4A4740"/>
+                </a:solidFill>
+                <a:latin typeface="Calibri"/>
+              </a:rPr>
+              <a:t>.</a:t>
             </a:r>
           </a:p>
           <a:p>
@@ -8439,13 +8724,31 @@
               </a:spcAft>
             </a:pPr>
             <a:r>
-              <a:rPr sz="1550" b="0">
+              <a:rPr sz="1550" b="0" dirty="0">
                 <a:solidFill>
                   <a:srgbClr val="4A4740"/>
                 </a:solidFill>
                 <a:latin typeface="Calibri"/>
               </a:rPr>
-              <a:t>—  It is adaptive, not damage. It was a reasonable strategy where it was learned. It does not transfer here.</a:t>
+              <a:t>—It was a </a:t>
+            </a:r>
+            <a:r>
+              <a:rPr lang="en-US" sz="1550" b="0" dirty="0">
+                <a:solidFill>
+                  <a:srgbClr val="4A4740"/>
+                </a:solidFill>
+                <a:latin typeface="Calibri"/>
+              </a:rPr>
+              <a:t>successful</a:t>
+            </a:r>
+            <a:r>
+              <a:rPr sz="1550" b="0" dirty="0">
+                <a:solidFill>
+                  <a:srgbClr val="4A4740"/>
+                </a:solidFill>
+                <a:latin typeface="Calibri"/>
+              </a:rPr>
+              <a:t> strategy where it was learned. It does not transfer here.</a:t>
             </a:r>
           </a:p>
         </p:txBody>
@@ -8537,7 +8840,7 @@
 </file>
 
 <file path=ppt/slides/slide22.xml><?xml version="1.0" encoding="utf-8"?>
-<p:sld xmlns:a="http://schemas.openxmlformats.org/drawingml/2006/main" xmlns:p="http://schemas.openxmlformats.org/presentationml/2006/main" xmlns:r="http://schemas.openxmlformats.org/officeDocument/2006/relationships">
+<p:sld xmlns:a="http://schemas.openxmlformats.org/drawingml/2006/main" xmlns:r="http://schemas.openxmlformats.org/officeDocument/2006/relationships" xmlns:p="http://schemas.openxmlformats.org/presentationml/2006/main">
   <p:cSld>
     <p:bg>
       <p:bgPr>
@@ -8553,7 +8856,14 @@
         <p:cNvGrpSpPr/>
         <p:nvPr/>
       </p:nvGrpSpPr>
-      <p:grpSpPr/>
+      <p:grpSpPr>
+        <a:xfrm>
+          <a:off x="0" y="0"/>
+          <a:ext cx="0" cy="0"/>
+          <a:chOff x="0" y="0"/>
+          <a:chExt cx="0" cy="0"/>
+        </a:xfrm>
+      </p:grpSpPr>
       <p:sp>
         <p:nvSpPr>
           <p:cNvPr id="2" name="TextBox 1"/>
@@ -8675,6 +8985,7 @@
           <a:lstStyle/>
           <a:p>
             <a:pPr algn="ctr"/>
+            <a:endParaRPr/>
           </a:p>
         </p:txBody>
       </p:sp>
@@ -8726,7 +9037,7 @@
         <p:spPr>
           <a:xfrm>
             <a:off x="1033271" y="2679192"/>
-            <a:ext cx="4709160" cy="448056"/>
+            <a:ext cx="4709160" cy="495007"/>
           </a:xfrm>
           <a:prstGeom prst="rect">
             <a:avLst/>
@@ -8745,13 +9056,31 @@
               </a:lnSpc>
             </a:pPr>
             <a:r>
-              <a:rPr sz="1200" b="0" i="0">
+              <a:rPr sz="1200" b="0" i="0" dirty="0">
                 <a:solidFill>
                   <a:srgbClr val="4A4740"/>
                 </a:solidFill>
                 <a:latin typeface="Calibri"/>
               </a:rPr>
-              <a:t>Many people have not been asked in years what they actually care about — and whatever you choose exposes something.</a:t>
+              <a:t>Many people have not been asked in years what they actually care about — and whatever you choose </a:t>
+            </a:r>
+            <a:r>
+              <a:rPr lang="en-US" sz="1200" b="0" i="0" dirty="0">
+                <a:solidFill>
+                  <a:srgbClr val="4A4740"/>
+                </a:solidFill>
+                <a:latin typeface="Calibri"/>
+              </a:rPr>
+              <a:t>will be , by definition, revealing</a:t>
+            </a:r>
+            <a:r>
+              <a:rPr sz="1200" b="0" i="0" dirty="0">
+                <a:solidFill>
+                  <a:srgbClr val="4A4740"/>
+                </a:solidFill>
+                <a:latin typeface="Calibri"/>
+              </a:rPr>
+              <a:t>.</a:t>
             </a:r>
           </a:p>
         </p:txBody>
@@ -8799,6 +9128,7 @@
           <a:lstStyle/>
           <a:p>
             <a:pPr algn="ctr"/>
+            <a:endParaRPr/>
           </a:p>
         </p:txBody>
       </p:sp>
@@ -8850,7 +9180,7 @@
         <p:spPr>
           <a:xfrm>
             <a:off x="6473952" y="2679192"/>
-            <a:ext cx="4709160" cy="448056"/>
+            <a:ext cx="4709160" cy="478144"/>
           </a:xfrm>
           <a:prstGeom prst="rect">
             <a:avLst/>
@@ -8869,13 +9199,40 @@
               </a:lnSpc>
             </a:pPr>
             <a:r>
-              <a:rPr sz="1150" b="0" i="0">
+              <a:rPr lang="en-US" sz="1150" b="0" i="0" dirty="0">
                 <a:solidFill>
                   <a:srgbClr val="4A4740"/>
                 </a:solidFill>
                 <a:latin typeface="Calibri"/>
               </a:rPr>
-              <a:t>The floor of fifteen pushes past where you would have stopped. Items eight to fifteen are the ones you were not going to admit to.</a:t>
+              <a:t>The minimum of fif</a:t>
+            </a:r>
+            <a:r>
+              <a:rPr sz="1150" b="0" i="0" dirty="0">
+                <a:solidFill>
+                  <a:srgbClr val="4A4740"/>
+                </a:solidFill>
+                <a:latin typeface="Calibri"/>
+              </a:rPr>
+              <a:t>teen </a:t>
+            </a:r>
+            <a:r>
+              <a:rPr lang="en-US" sz="1150" dirty="0">
+                <a:solidFill>
+                  <a:srgbClr val="4A4740"/>
+                </a:solidFill>
+                <a:latin typeface="Calibri"/>
+              </a:rPr>
+              <a:t>items/words may </a:t>
+            </a:r>
+            <a:r>
+              <a:rPr sz="1150" b="0" i="0" dirty="0">
+                <a:solidFill>
+                  <a:srgbClr val="4A4740"/>
+                </a:solidFill>
+                <a:latin typeface="Calibri"/>
+              </a:rPr>
+              <a:t>push past where you would have stopped.</a:t>
             </a:r>
           </a:p>
         </p:txBody>
@@ -8923,6 +9280,7 @@
           <a:lstStyle/>
           <a:p>
             <a:pPr algn="ctr"/>
+            <a:endParaRPr/>
           </a:p>
         </p:txBody>
       </p:sp>
@@ -8974,7 +9332,7 @@
         <p:spPr>
           <a:xfrm>
             <a:off x="1033271" y="4050791"/>
-            <a:ext cx="4709160" cy="448056"/>
+            <a:ext cx="4709160" cy="495007"/>
           </a:xfrm>
           <a:prstGeom prst="rect">
             <a:avLst/>
@@ -8993,14 +9351,29 @@
               </a:lnSpc>
             </a:pPr>
             <a:r>
-              <a:rPr sz="1200" b="0" i="0">
+              <a:rPr sz="1200" b="0" i="0" dirty="0">
                 <a:solidFill>
                   <a:srgbClr val="4A4740"/>
                 </a:solidFill>
                 <a:latin typeface="Calibri"/>
               </a:rPr>
-              <a:t>You select without being asked to justify it, and can spend the whole step bracing for a question that never comes.</a:t>
-            </a:r>
+              <a:t>You select without being asked to justify it and </a:t>
+            </a:r>
+            <a:r>
+              <a:rPr lang="en-US" sz="1200" b="0" i="0" dirty="0">
+                <a:solidFill>
+                  <a:srgbClr val="4A4740"/>
+                </a:solidFill>
+                <a:latin typeface="Calibri"/>
+              </a:rPr>
+              <a:t>without any one to judge or admire your choices.</a:t>
+            </a:r>
+            <a:endParaRPr sz="1200" b="0" i="0" dirty="0">
+              <a:solidFill>
+                <a:srgbClr val="4A4740"/>
+              </a:solidFill>
+              <a:latin typeface="Calibri"/>
+            </a:endParaRPr>
           </a:p>
         </p:txBody>
       </p:sp>
@@ -9047,6 +9420,7 @@
           <a:lstStyle/>
           <a:p>
             <a:pPr algn="ctr"/>
+            <a:endParaRPr/>
           </a:p>
         </p:txBody>
       </p:sp>
@@ -9098,7 +9472,7 @@
         <p:spPr>
           <a:xfrm>
             <a:off x="6473952" y="4050791"/>
-            <a:ext cx="4709160" cy="448056"/>
+            <a:ext cx="4709160" cy="495007"/>
           </a:xfrm>
           <a:prstGeom prst="rect">
             <a:avLst/>
@@ -9117,13 +9491,31 @@
               </a:lnSpc>
             </a:pPr>
             <a:r>
-              <a:rPr sz="1200" b="0" i="0">
+              <a:rPr sz="1200" b="0" i="0" dirty="0">
                 <a:solidFill>
                   <a:srgbClr val="4A4740"/>
                 </a:solidFill>
                 <a:latin typeface="Calibri"/>
               </a:rPr>
-              <a:t>Naming a relationship is where vocabulary insecurity lives, in anyone who has been corrected on their words.</a:t>
+              <a:t>Naming </a:t>
+            </a:r>
+            <a:r>
+              <a:rPr lang="en-US" sz="1200" dirty="0">
+                <a:solidFill>
+                  <a:srgbClr val="4A4740"/>
+                </a:solidFill>
+                <a:latin typeface="Calibri"/>
+              </a:rPr>
+              <a:t>things in writing can remind us of how we felt when being “corrected” in class</a:t>
+            </a:r>
+            <a:r>
+              <a:rPr sz="1200" b="0" i="0" dirty="0">
+                <a:solidFill>
+                  <a:srgbClr val="4A4740"/>
+                </a:solidFill>
+                <a:latin typeface="Calibri"/>
+              </a:rPr>
+              <a:t>.</a:t>
             </a:r>
           </a:p>
         </p:txBody>
@@ -9171,6 +9563,7 @@
           <a:lstStyle/>
           <a:p>
             <a:pPr algn="ctr"/>
+            <a:endParaRPr/>
           </a:p>
         </p:txBody>
       </p:sp>
@@ -9221,8 +9614,8 @@
         </p:nvSpPr>
         <p:spPr>
           <a:xfrm>
-            <a:off x="1033271" y="5422392"/>
-            <a:ext cx="4709160" cy="448056"/>
+            <a:off x="1033271" y="5205405"/>
+            <a:ext cx="4910329" cy="676339"/>
           </a:xfrm>
           <a:prstGeom prst="rect">
             <a:avLst/>
@@ -9241,13 +9634,49 @@
               </a:lnSpc>
             </a:pPr>
             <a:r>
-              <a:rPr sz="1150" b="0" i="0">
+              <a:rPr sz="1150" b="0" i="0" dirty="0">
                 <a:solidFill>
                   <a:srgbClr val="4A4740"/>
                 </a:solidFill>
                 <a:latin typeface="Calibri"/>
               </a:rPr>
-              <a:t>Erasing has usually meant you were wrong. Here it means the work is progressing. Understanding that is easy; feeling it is not.</a:t>
+              <a:t>Erasing has </a:t>
+            </a:r>
+            <a:r>
+              <a:rPr lang="en-US" sz="1150" dirty="0">
+                <a:solidFill>
+                  <a:srgbClr val="4A4740"/>
+                </a:solidFill>
+                <a:latin typeface="Calibri"/>
+              </a:rPr>
+              <a:t>often</a:t>
+            </a:r>
+            <a:r>
+              <a:rPr sz="1150" b="0" i="0" dirty="0">
+                <a:solidFill>
+                  <a:srgbClr val="4A4740"/>
+                </a:solidFill>
+                <a:latin typeface="Calibri"/>
+              </a:rPr>
+              <a:t> meant you were wrong. Here it means the work is progressing. Understanding that is easy; feeling </a:t>
+            </a:r>
+            <a:r>
+              <a:rPr lang="en-US" sz="1150" b="0" i="0" dirty="0">
+                <a:solidFill>
+                  <a:srgbClr val="4A4740"/>
+                </a:solidFill>
+                <a:latin typeface="Calibri"/>
+              </a:rPr>
+              <a:t>good about it may not come so easily. Trial and error is real leaning, not compliance and memorization</a:t>
+            </a:r>
+            <a:r>
+              <a:rPr sz="1150" b="0" i="0" dirty="0">
+                <a:solidFill>
+                  <a:srgbClr val="4A4740"/>
+                </a:solidFill>
+                <a:latin typeface="Calibri"/>
+              </a:rPr>
+              <a:t>.</a:t>
             </a:r>
           </a:p>
         </p:txBody>
@@ -9295,6 +9724,7 @@
           <a:lstStyle/>
           <a:p>
             <a:pPr algn="ctr"/>
+            <a:endParaRPr/>
           </a:p>
         </p:txBody>
       </p:sp>
@@ -9346,7 +9776,7 @@
         <p:spPr>
           <a:xfrm>
             <a:off x="6473952" y="5422392"/>
-            <a:ext cx="4709160" cy="448056"/>
+            <a:ext cx="4709160" cy="495007"/>
           </a:xfrm>
           <a:prstGeom prst="rect">
             <a:avLst/>
@@ -9365,13 +9795,31 @@
               </a:lnSpc>
             </a:pPr>
             <a:r>
-              <a:rPr sz="1200" b="0" i="0">
+              <a:rPr sz="1200" b="0" i="0" dirty="0">
                 <a:solidFill>
                   <a:srgbClr val="4A4740"/>
                 </a:solidFill>
                 <a:latin typeface="Calibri"/>
               </a:rPr>
-              <a:t>Reading your own work aloud is a familiar place to be humiliated — and now there is nobody to say whether it was any good.</a:t>
+              <a:t>Reading your own work aloud is a familiar place to be humiliated — and now there is nobody to </a:t>
+            </a:r>
+            <a:r>
+              <a:rPr lang="en-US" sz="1200" b="0" i="0" dirty="0">
+                <a:solidFill>
+                  <a:srgbClr val="4A4740"/>
+                </a:solidFill>
+                <a:latin typeface="Calibri"/>
+              </a:rPr>
+              <a:t>criticize or praise</a:t>
+            </a:r>
+            <a:r>
+              <a:rPr sz="1200" b="0" i="0" dirty="0">
+                <a:solidFill>
+                  <a:srgbClr val="4A4740"/>
+                </a:solidFill>
+                <a:latin typeface="Calibri"/>
+              </a:rPr>
+              <a:t>.</a:t>
             </a:r>
           </a:p>
         </p:txBody>
@@ -9463,7 +9911,7 @@
 </file>
 
 <file path=ppt/slides/slide23.xml><?xml version="1.0" encoding="utf-8"?>
-<p:sld xmlns:a="http://schemas.openxmlformats.org/drawingml/2006/main" xmlns:p="http://schemas.openxmlformats.org/presentationml/2006/main" xmlns:r="http://schemas.openxmlformats.org/officeDocument/2006/relationships">
+<p:sld xmlns:a="http://schemas.openxmlformats.org/drawingml/2006/main" xmlns:r="http://schemas.openxmlformats.org/officeDocument/2006/relationships" xmlns:p="http://schemas.openxmlformats.org/presentationml/2006/main">
   <p:cSld>
     <p:bg>
       <p:bgPr>
@@ -9479,7 +9927,14 @@
         <p:cNvGrpSpPr/>
         <p:nvPr/>
       </p:nvGrpSpPr>
-      <p:grpSpPr/>
+      <p:grpSpPr>
+        <a:xfrm>
+          <a:off x="0" y="0"/>
+          <a:ext cx="0" cy="0"/>
+          <a:chOff x="0" y="0"/>
+          <a:chExt cx="0" cy="0"/>
+        </a:xfrm>
+      </p:grpSpPr>
       <p:sp>
         <p:nvSpPr>
           <p:cNvPr id="2" name="TextBox 1"/>
@@ -9601,6 +10056,7 @@
           <a:lstStyle/>
           <a:p>
             <a:pPr algn="ctr"/>
+            <a:endParaRPr/>
           </a:p>
         </p:txBody>
       </p:sp>
@@ -9652,7 +10108,7 @@
         <p:spPr>
           <a:xfrm>
             <a:off x="1051560" y="2788920"/>
-            <a:ext cx="4572000" cy="1005840"/>
+            <a:ext cx="4572000" cy="820546"/>
           </a:xfrm>
           <a:prstGeom prst="rect">
             <a:avLst/>
@@ -9671,14 +10127,31 @@
               </a:lnSpc>
             </a:pPr>
             <a:r>
-              <a:rPr sz="2300" b="1" i="0">
+              <a:rPr sz="2300" b="1" i="0" dirty="0">
                 <a:solidFill>
                   <a:srgbClr val="14130F"/>
                 </a:solidFill>
                 <a:latin typeface="Calibri"/>
               </a:rPr>
-              <a:t>A student who had
-left school</a:t>
+              <a:t>A student who had</a:t>
+            </a:r>
+            <a:r>
+              <a:rPr lang="en-US" sz="2300" b="1" i="0" dirty="0">
+                <a:solidFill>
+                  <a:srgbClr val="14130F"/>
+                </a:solidFill>
+                <a:latin typeface="Calibri"/>
+              </a:rPr>
+              <a:t> quit attending high</a:t>
+            </a:r>
+            <a:r>
+              <a:rPr sz="2300" b="1" i="0" dirty="0">
+                <a:solidFill>
+                  <a:srgbClr val="14130F"/>
+                </a:solidFill>
+                <a:latin typeface="Calibri"/>
+              </a:rPr>
+              <a:t> school</a:t>
             </a:r>
           </a:p>
         </p:txBody>
@@ -9726,6 +10199,7 @@
           <a:lstStyle/>
           <a:p>
             <a:pPr algn="ctr"/>
+            <a:endParaRPr/>
           </a:p>
         </p:txBody>
       </p:sp>
@@ -9855,7 +10329,7 @@
         <p:spPr>
           <a:xfrm>
             <a:off x="777240" y="4800600"/>
-            <a:ext cx="10332720" cy="914400"/>
+            <a:ext cx="10332720" cy="685059"/>
           </a:xfrm>
           <a:prstGeom prst="rect">
             <a:avLst/>
@@ -9874,13 +10348,49 @@
               </a:lnSpc>
             </a:pPr>
             <a:r>
-              <a:rPr sz="1600" b="0" i="0">
+              <a:rPr sz="1600" b="0" i="0" dirty="0">
                 <a:solidFill>
                   <a:srgbClr val="14130F"/>
                 </a:solidFill>
                 <a:latin typeface="Calibri"/>
               </a:rPr>
-              <a:t>That ordering is the reverse of what most schools would predict about those two people. It is what you would expect if the difficulty tracks years of successful submission to judgement rather than years of education.</a:t>
+              <a:t>That ordering is the reverse of what most schools would predict about those two people. It is what you would expect if the difficulty tracks years of successful </a:t>
+            </a:r>
+            <a:r>
+              <a:rPr lang="en-US" sz="1600" b="0" i="0" dirty="0">
+                <a:solidFill>
+                  <a:srgbClr val="14130F"/>
+                </a:solidFill>
+                <a:latin typeface="Calibri"/>
+              </a:rPr>
+              <a:t>adaptation</a:t>
+            </a:r>
+            <a:r>
+              <a:rPr sz="1600" b="0" i="0" dirty="0">
+                <a:solidFill>
+                  <a:srgbClr val="14130F"/>
+                </a:solidFill>
+                <a:latin typeface="Calibri"/>
+              </a:rPr>
+              <a:t> to judgement rather than years of </a:t>
+            </a:r>
+            <a:r>
+              <a:rPr lang="en-US" sz="1600" b="0" i="0" dirty="0">
+                <a:solidFill>
+                  <a:srgbClr val="14130F"/>
+                </a:solidFill>
+                <a:latin typeface="Calibri"/>
+              </a:rPr>
+              <a:t>freestyle learning</a:t>
+            </a:r>
+            <a:r>
+              <a:rPr sz="1600" b="0" i="0" dirty="0">
+                <a:solidFill>
+                  <a:srgbClr val="14130F"/>
+                </a:solidFill>
+                <a:latin typeface="Calibri"/>
+              </a:rPr>
+              <a:t>.</a:t>
             </a:r>
           </a:p>
         </p:txBody>
@@ -10011,7 +10521,7 @@
 </file>
 
 <file path=ppt/slides/slide24.xml><?xml version="1.0" encoding="utf-8"?>
-<p:sld xmlns:a="http://schemas.openxmlformats.org/drawingml/2006/main" xmlns:p="http://schemas.openxmlformats.org/presentationml/2006/main" xmlns:r="http://schemas.openxmlformats.org/officeDocument/2006/relationships">
+<p:sld xmlns:a="http://schemas.openxmlformats.org/drawingml/2006/main" xmlns:r="http://schemas.openxmlformats.org/officeDocument/2006/relationships" xmlns:p="http://schemas.openxmlformats.org/presentationml/2006/main">
   <p:cSld>
     <p:bg>
       <p:bgPr>
@@ -10027,7 +10537,14 @@
         <p:cNvGrpSpPr/>
         <p:nvPr/>
       </p:nvGrpSpPr>
-      <p:grpSpPr/>
+      <p:grpSpPr>
+        <a:xfrm>
+          <a:off x="0" y="0"/>
+          <a:ext cx="0" cy="0"/>
+          <a:chOff x="0" y="0"/>
+          <a:chExt cx="0" cy="0"/>
+        </a:xfrm>
+      </p:grpSpPr>
       <p:sp>
         <p:nvSpPr>
           <p:cNvPr id="2" name="TextBox 1"/>
@@ -10149,6 +10666,7 @@
           <a:lstStyle/>
           <a:p>
             <a:pPr algn="ctr"/>
+            <a:endParaRPr/>
           </a:p>
         </p:txBody>
       </p:sp>
@@ -10200,7 +10718,7 @@
         <p:spPr>
           <a:xfrm>
             <a:off x="1033271" y="2907792"/>
-            <a:ext cx="4709160" cy="859536"/>
+            <a:ext cx="4709160" cy="777970"/>
           </a:xfrm>
           <a:prstGeom prst="rect">
             <a:avLst/>
@@ -10219,7 +10737,7 @@
               </a:lnSpc>
             </a:pPr>
             <a:r>
-              <a:rPr sz="1350" b="0" i="0">
+              <a:rPr sz="1350" b="0" i="0" dirty="0">
                 <a:solidFill>
                   <a:srgbClr val="4A4740"/>
                 </a:solidFill>
@@ -10227,6 +10745,21 @@
               </a:rPr>
               <a:t>Do not hand it over and ask what they think. Read it to them. The difference matters and you will feel it.</a:t>
             </a:r>
+            <a:r>
+              <a:rPr lang="en-US" sz="1350" b="0" i="0" dirty="0">
+                <a:solidFill>
+                  <a:srgbClr val="4A4740"/>
+                </a:solidFill>
+                <a:latin typeface="Calibri"/>
+              </a:rPr>
+              <a:t> Edit it if you choose. It is entirely yours.</a:t>
+            </a:r>
+            <a:endParaRPr sz="1350" b="0" i="0" dirty="0">
+              <a:solidFill>
+                <a:srgbClr val="4A4740"/>
+              </a:solidFill>
+              <a:latin typeface="Calibri"/>
+            </a:endParaRPr>
           </a:p>
         </p:txBody>
       </p:sp>
@@ -10273,6 +10806,7 @@
           <a:lstStyle/>
           <a:p>
             <a:pPr algn="ctr"/>
+            <a:endParaRPr/>
           </a:p>
         </p:txBody>
       </p:sp>
@@ -10304,14 +10838,29 @@
               </a:lnSpc>
             </a:pPr>
             <a:r>
-              <a:rPr sz="1700" b="1" i="0">
+              <a:rPr sz="1700" b="1" i="0" dirty="0">
                 <a:solidFill>
                   <a:srgbClr val="14130F"/>
                 </a:solidFill>
                 <a:latin typeface="Calibri"/>
               </a:rPr>
-              <a:t>Do not tidy it up</a:t>
-            </a:r>
+              <a:t>Do not </a:t>
+            </a:r>
+            <a:r>
+              <a:rPr lang="en-US" sz="1700" b="1" i="0" dirty="0">
+                <a:solidFill>
+                  <a:srgbClr val="14130F"/>
+                </a:solidFill>
+                <a:latin typeface="Calibri"/>
+              </a:rPr>
+              <a:t>discard the “original”</a:t>
+            </a:r>
+            <a:endParaRPr sz="1700" b="1" i="0" dirty="0">
+              <a:solidFill>
+                <a:srgbClr val="14130F"/>
+              </a:solidFill>
+              <a:latin typeface="Calibri"/>
+            </a:endParaRPr>
           </a:p>
         </p:txBody>
       </p:sp>
@@ -10324,33 +10873,47 @@
         <p:spPr>
           <a:xfrm>
             <a:off x="6473952" y="2907792"/>
-            <a:ext cx="4709160" cy="859536"/>
-          </a:xfrm>
-          <a:prstGeom prst="rect">
-            <a:avLst/>
-          </a:prstGeom>
-          <a:noFill/>
-        </p:spPr>
-        <p:txBody>
-          <a:bodyPr wrap="square" anchor="t">
-            <a:spAutoFit/>
-          </a:bodyPr>
-          <a:lstStyle/>
-          <a:p>
-            <a:pPr algn="l">
+            <a:ext cx="4709160" cy="545277"/>
+          </a:xfrm>
+          <a:prstGeom prst="rect">
+            <a:avLst/>
+          </a:prstGeom>
+          <a:noFill/>
+        </p:spPr>
+        <p:txBody>
+          <a:bodyPr wrap="square" anchor="t">
+            <a:spAutoFit/>
+          </a:bodyPr>
+          <a:lstStyle/>
+          <a:p>
+            <a:pPr>
               <a:lnSpc>
                 <a:spcPct val="112000"/>
               </a:lnSpc>
             </a:pPr>
             <a:r>
-              <a:rPr sz="1350" b="0" i="0">
+              <a:rPr sz="1350" b="0" i="0" dirty="0">
                 <a:solidFill>
                   <a:srgbClr val="4A4740"/>
                 </a:solidFill>
                 <a:latin typeface="Calibri"/>
               </a:rPr>
-              <a:t>The wobbly version is the one you made. A neat copy is a different object and usually a worse one.</a:t>
-            </a:r>
+              <a:t>The wobbly version is the one you made. A neat copy is a different object</a:t>
+            </a:r>
+            <a:r>
+              <a:rPr lang="en-US" sz="1350" dirty="0">
+                <a:solidFill>
+                  <a:srgbClr val="4A4740"/>
+                </a:solidFill>
+              </a:rPr>
+              <a:t>. Edit it if you choose. It is entirely yours.</a:t>
+            </a:r>
+            <a:endParaRPr sz="1350" b="0" i="0" dirty="0">
+              <a:solidFill>
+                <a:srgbClr val="4A4740"/>
+              </a:solidFill>
+              <a:latin typeface="Calibri"/>
+            </a:endParaRPr>
           </a:p>
         </p:txBody>
       </p:sp>
@@ -10397,6 +10960,7 @@
           <a:lstStyle/>
           <a:p>
             <a:pPr algn="ctr"/>
+            <a:endParaRPr/>
           </a:p>
         </p:txBody>
       </p:sp>
@@ -10428,13 +10992,22 @@
               </a:lnSpc>
             </a:pPr>
             <a:r>
-              <a:rPr sz="1700" b="1" i="0">
+              <a:rPr lang="en-US" sz="1700" b="1" i="0" dirty="0">
                 <a:solidFill>
                   <a:srgbClr val="14130F"/>
                 </a:solidFill>
                 <a:latin typeface="Calibri"/>
               </a:rPr>
-              <a:t>Draw it again in a month</a:t>
+              <a:t>Do it all over</a:t>
+            </a:r>
+            <a:r>
+              <a:rPr sz="1700" b="1" i="0" dirty="0">
+                <a:solidFill>
+                  <a:srgbClr val="14130F"/>
+                </a:solidFill>
+                <a:latin typeface="Calibri"/>
+              </a:rPr>
+              <a:t> in a month</a:t>
             </a:r>
           </a:p>
         </p:txBody>
@@ -10521,6 +11094,7 @@
           <a:lstStyle/>
           <a:p>
             <a:pPr algn="ctr"/>
+            <a:endParaRPr/>
           </a:p>
         </p:txBody>
       </p:sp>
@@ -10689,7 +11263,7 @@
 </file>
 
 <file path=ppt/slides/slide25.xml><?xml version="1.0" encoding="utf-8"?>
-<p:sld xmlns:a="http://schemas.openxmlformats.org/drawingml/2006/main" xmlns:p="http://schemas.openxmlformats.org/presentationml/2006/main" xmlns:r="http://schemas.openxmlformats.org/officeDocument/2006/relationships">
+<p:sld xmlns:a="http://schemas.openxmlformats.org/drawingml/2006/main" xmlns:r="http://schemas.openxmlformats.org/officeDocument/2006/relationships" xmlns:p="http://schemas.openxmlformats.org/presentationml/2006/main">
   <p:cSld>
     <p:bg>
       <p:bgPr>
@@ -10705,7 +11279,14 @@
         <p:cNvGrpSpPr/>
         <p:nvPr/>
       </p:nvGrpSpPr>
-      <p:grpSpPr/>
+      <p:grpSpPr>
+        <a:xfrm>
+          <a:off x="0" y="0"/>
+          <a:ext cx="0" cy="0"/>
+          <a:chOff x="0" y="0"/>
+          <a:chExt cx="0" cy="0"/>
+        </a:xfrm>
+      </p:grpSpPr>
       <p:sp>
         <p:nvSpPr>
           <p:cNvPr id="2" name="TextBox 1"/>
@@ -10754,7 +11335,7 @@
         <p:spPr>
           <a:xfrm>
             <a:off x="777240" y="868680"/>
-            <a:ext cx="10607040" cy="1188720"/>
+            <a:ext cx="10607040" cy="1086451"/>
           </a:xfrm>
           <a:prstGeom prst="rect">
             <a:avLst/>
@@ -10773,13 +11354,40 @@
               </a:lnSpc>
             </a:pPr>
             <a:r>
-              <a:rPr sz="3400" b="1" i="0">
+              <a:rPr lang="en-US" sz="3400" b="1" i="0" dirty="0">
                 <a:solidFill>
                   <a:srgbClr val="14130F"/>
                 </a:solidFill>
                 <a:latin typeface="Calibri"/>
               </a:rPr>
-              <a:t>Running it is easy. Not helping is hard.</a:t>
+              <a:t>If you are in the room helping people step through</a:t>
+            </a:r>
+            <a:r>
+              <a:rPr sz="3400" b="1" i="0" dirty="0">
+                <a:solidFill>
+                  <a:srgbClr val="14130F"/>
+                </a:solidFill>
+                <a:latin typeface="Calibri"/>
+              </a:rPr>
+              <a:t> it is easy. Not </a:t>
+            </a:r>
+            <a:r>
+              <a:rPr lang="en-US" sz="3400" b="1" i="0" dirty="0">
+                <a:solidFill>
+                  <a:srgbClr val="14130F"/>
+                </a:solidFill>
+                <a:latin typeface="Calibri"/>
+              </a:rPr>
+              <a:t>intervening may be</a:t>
+            </a:r>
+            <a:r>
+              <a:rPr sz="3400" b="1" i="0" dirty="0">
+                <a:solidFill>
+                  <a:srgbClr val="14130F"/>
+                </a:solidFill>
+                <a:latin typeface="Calibri"/>
+              </a:rPr>
+              <a:t> hard.</a:t>
             </a:r>
           </a:p>
         </p:txBody>
@@ -10827,6 +11435,7 @@
           <a:lstStyle/>
           <a:p>
             <a:pPr algn="ctr"/>
+            <a:endParaRPr/>
           </a:p>
         </p:txBody>
       </p:sp>
@@ -10878,7 +11487,7 @@
         <p:spPr>
           <a:xfrm>
             <a:off x="1033271" y="3044952"/>
-            <a:ext cx="2880360" cy="1545336"/>
+            <a:ext cx="2880360" cy="942566"/>
           </a:xfrm>
           <a:prstGeom prst="rect">
             <a:avLst/>
@@ -10897,13 +11506,31 @@
               </a:lnSpc>
             </a:pPr>
             <a:r>
-              <a:rPr sz="1250" b="0" i="0">
+              <a:rPr sz="1250" b="0" i="0" dirty="0">
                 <a:solidFill>
                   <a:srgbClr val="4A4740"/>
                 </a:solidFill>
                 <a:latin typeface="Calibri"/>
               </a:rPr>
-              <a:t>Say plainly, before they start, that you will not look at their work and will not help. Silence that has not been declared is not a withdrawal of judgement. It is surveillance, and it is worse than marking.</a:t>
+              <a:t>Say plainly, before they start, that you will not look at their work and will not help. </a:t>
+            </a:r>
+            <a:r>
+              <a:rPr lang="en-US" sz="1250" b="0" i="0" dirty="0">
+                <a:solidFill>
+                  <a:srgbClr val="4A4740"/>
+                </a:solidFill>
+                <a:latin typeface="Calibri"/>
+              </a:rPr>
+              <a:t>Avoid anything that could be interpreted or felt as </a:t>
+            </a:r>
+            <a:r>
+              <a:rPr sz="1250" b="0" i="0" dirty="0">
+                <a:solidFill>
+                  <a:srgbClr val="4A4740"/>
+                </a:solidFill>
+                <a:latin typeface="Calibri"/>
+              </a:rPr>
+              <a:t>surveillance.</a:t>
             </a:r>
           </a:p>
         </p:txBody>
@@ -10951,6 +11578,7 @@
           <a:lstStyle/>
           <a:p>
             <a:pPr algn="ctr"/>
+            <a:endParaRPr/>
           </a:p>
         </p:txBody>
       </p:sp>
@@ -11002,7 +11630,7 @@
         <p:spPr>
           <a:xfrm>
             <a:off x="4645152" y="3044952"/>
-            <a:ext cx="2880360" cy="1545336"/>
+            <a:ext cx="2880360" cy="942566"/>
           </a:xfrm>
           <a:prstGeom prst="rect">
             <a:avLst/>
@@ -11021,13 +11649,13 @@
               </a:lnSpc>
             </a:pPr>
             <a:r>
-              <a:rPr sz="1250" b="0" i="0">
+              <a:rPr sz="1250" b="0" i="0" dirty="0">
                 <a:solidFill>
                   <a:srgbClr val="4A4740"/>
                 </a:solidFill>
                 <a:latin typeface="Calibri"/>
               </a:rPr>
-              <a:t>Do your own unrelated work while they draw. Not sitting attentively, not available if needed. Being visibly occupied is the proof that the declaration was true.</a:t>
+              <a:t>Do your own unrelated work while they draw. Not sitting attentively. Being visibly occupied is the proof that the declaration was true.</a:t>
             </a:r>
           </a:p>
         </p:txBody>
@@ -11075,6 +11703,7 @@
           <a:lstStyle/>
           <a:p>
             <a:pPr algn="ctr"/>
+            <a:endParaRPr/>
           </a:p>
         </p:txBody>
       </p:sp>
@@ -11126,7 +11755,7 @@
         <p:spPr>
           <a:xfrm>
             <a:off x="8257031" y="3044952"/>
-            <a:ext cx="2880360" cy="1545336"/>
+            <a:ext cx="2880360" cy="1373453"/>
           </a:xfrm>
           <a:prstGeom prst="rect">
             <a:avLst/>
@@ -11145,13 +11774,121 @@
               </a:lnSpc>
             </a:pPr>
             <a:r>
-              <a:rPr sz="1250" b="0" i="0">
+              <a:rPr sz="1250" b="0" i="0" dirty="0">
                 <a:solidFill>
                   <a:srgbClr val="4A4740"/>
                 </a:solidFill>
                 <a:latin typeface="Calibri"/>
               </a:rPr>
-              <a:t>They will ask. They will ask repeatedly, and some will ask in ways that are hard to refuse. Every refusal re-confirms the rule.</a:t>
+              <a:t>They </a:t>
+            </a:r>
+            <a:r>
+              <a:rPr lang="en-US" sz="1250" b="0" i="0" dirty="0">
+                <a:solidFill>
+                  <a:srgbClr val="4A4740"/>
+                </a:solidFill>
+                <a:latin typeface="Calibri"/>
+              </a:rPr>
+              <a:t>may</a:t>
+            </a:r>
+            <a:r>
+              <a:rPr sz="1250" b="0" i="0" dirty="0">
+                <a:solidFill>
+                  <a:srgbClr val="4A4740"/>
+                </a:solidFill>
+                <a:latin typeface="Calibri"/>
+              </a:rPr>
+              <a:t> ask</a:t>
+            </a:r>
+            <a:r>
+              <a:rPr lang="en-US" sz="1250" b="0" i="0" dirty="0">
+                <a:solidFill>
+                  <a:srgbClr val="4A4740"/>
+                </a:solidFill>
+                <a:latin typeface="Calibri"/>
+              </a:rPr>
+              <a:t> for more than is provided. Encourage them to use what is given and not to worry.</a:t>
+            </a:r>
+            <a:r>
+              <a:rPr sz="1250" b="0" i="0" dirty="0">
+                <a:solidFill>
+                  <a:srgbClr val="4A4740"/>
+                </a:solidFill>
+                <a:latin typeface="Calibri"/>
+              </a:rPr>
+              <a:t> </a:t>
+            </a:r>
+            <a:r>
+              <a:rPr lang="en-US" sz="1250" b="0" i="0" dirty="0">
+                <a:solidFill>
+                  <a:srgbClr val="4A4740"/>
+                </a:solidFill>
+                <a:latin typeface="Calibri"/>
+              </a:rPr>
+              <a:t>Some</a:t>
+            </a:r>
+            <a:r>
+              <a:rPr sz="1250" b="0" i="0" dirty="0">
+                <a:solidFill>
+                  <a:srgbClr val="4A4740"/>
+                </a:solidFill>
+                <a:latin typeface="Calibri"/>
+              </a:rPr>
+              <a:t> </a:t>
+            </a:r>
+            <a:r>
+              <a:rPr lang="en-US" sz="1250" b="0" i="0" dirty="0">
+                <a:solidFill>
+                  <a:srgbClr val="4A4740"/>
+                </a:solidFill>
+                <a:latin typeface="Calibri"/>
+              </a:rPr>
+              <a:t>may</a:t>
+            </a:r>
+            <a:r>
+              <a:rPr sz="1250" b="0" i="0" dirty="0">
+                <a:solidFill>
+                  <a:srgbClr val="4A4740"/>
+                </a:solidFill>
+                <a:latin typeface="Calibri"/>
+              </a:rPr>
+              <a:t> ask repeatedly, and some will ask in ways that are hard to refuse. </a:t>
+            </a:r>
+            <a:r>
+              <a:rPr lang="en-US" sz="1250" dirty="0">
+                <a:solidFill>
+                  <a:srgbClr val="4A4740"/>
+                </a:solidFill>
+                <a:latin typeface="Calibri"/>
+              </a:rPr>
+              <a:t>R</a:t>
+            </a:r>
+            <a:r>
+              <a:rPr sz="1250" b="0" i="0" dirty="0">
+                <a:solidFill>
+                  <a:srgbClr val="4A4740"/>
+                </a:solidFill>
+                <a:latin typeface="Calibri"/>
+              </a:rPr>
+              <a:t>e-confirm</a:t>
+            </a:r>
+            <a:r>
+              <a:rPr lang="en-US" sz="1250" b="0" i="0" dirty="0">
+                <a:solidFill>
+                  <a:srgbClr val="4A4740"/>
+                </a:solidFill>
+                <a:latin typeface="Calibri"/>
+              </a:rPr>
+              <a:t> that this is theirs to play with, not yours</a:t>
+            </a:r>
+            <a:r>
+              <a:rPr sz="1250" b="0" i="0" dirty="0">
+                <a:solidFill>
+                  <a:srgbClr val="4A4740"/>
+                </a:solidFill>
+                <a:latin typeface="Calibri"/>
+              </a:rPr>
+              <a:t>.</a:t>
             </a:r>
           </a:p>
         </p:txBody>
@@ -11199,6 +11936,7 @@
           <a:lstStyle/>
           <a:p>
             <a:pPr algn="ctr"/>
+            <a:endParaRPr/>
           </a:p>
         </p:txBody>
       </p:sp>
@@ -11328,7 +12066,7 @@
 </file>
 
 <file path=ppt/slides/slide26.xml><?xml version="1.0" encoding="utf-8"?>
-<p:sld xmlns:a="http://schemas.openxmlformats.org/drawingml/2006/main" xmlns:p="http://schemas.openxmlformats.org/presentationml/2006/main" xmlns:r="http://schemas.openxmlformats.org/officeDocument/2006/relationships">
+<p:sld xmlns:a="http://schemas.openxmlformats.org/drawingml/2006/main" xmlns:r="http://schemas.openxmlformats.org/officeDocument/2006/relationships" xmlns:p="http://schemas.openxmlformats.org/presentationml/2006/main">
   <p:cSld>
     <p:bg>
       <p:bgPr>
@@ -11344,7 +12082,14 @@
         <p:cNvGrpSpPr/>
         <p:nvPr/>
       </p:nvGrpSpPr>
-      <p:grpSpPr/>
+      <p:grpSpPr>
+        <a:xfrm>
+          <a:off x="0" y="0"/>
+          <a:ext cx="0" cy="0"/>
+          <a:chOff x="0" y="0"/>
+          <a:chExt cx="0" cy="0"/>
+        </a:xfrm>
+      </p:grpSpPr>
       <p:sp>
         <p:nvSpPr>
           <p:cNvPr id="2" name="TextBox 1"/>
@@ -11504,6 +12249,7 @@
           <a:lstStyle/>
           <a:p>
             <a:pPr algn="ctr"/>
+            <a:endParaRPr/>
           </a:p>
         </p:txBody>
       </p:sp>
@@ -11674,7 +12420,7 @@
 </file>
 
 <file path=ppt/slides/slide27.xml><?xml version="1.0" encoding="utf-8"?>
-<p:sld xmlns:a="http://schemas.openxmlformats.org/drawingml/2006/main" xmlns:p="http://schemas.openxmlformats.org/presentationml/2006/main" xmlns:r="http://schemas.openxmlformats.org/officeDocument/2006/relationships">
+<p:sld xmlns:a="http://schemas.openxmlformats.org/drawingml/2006/main" xmlns:r="http://schemas.openxmlformats.org/officeDocument/2006/relationships" xmlns:p="http://schemas.openxmlformats.org/presentationml/2006/main">
   <p:cSld>
     <p:bg>
       <p:bgPr>
@@ -11690,7 +12436,14 @@
         <p:cNvGrpSpPr/>
         <p:nvPr/>
       </p:nvGrpSpPr>
-      <p:grpSpPr/>
+      <p:grpSpPr>
+        <a:xfrm>
+          <a:off x="0" y="0"/>
+          <a:ext cx="0" cy="0"/>
+          <a:chOff x="0" y="0"/>
+          <a:chExt cx="0" cy="0"/>
+        </a:xfrm>
+      </p:grpSpPr>
       <p:sp>
         <p:nvSpPr>
           <p:cNvPr id="2" name="TextBox 1"/>
@@ -11812,6 +12565,7 @@
           <a:lstStyle/>
           <a:p>
             <a:pPr algn="ctr"/>
+            <a:endParaRPr/>
           </a:p>
         </p:txBody>
       </p:sp>
@@ -12034,6 +12788,7 @@
           <a:lstStyle/>
           <a:p>
             <a:pPr algn="ctr"/>
+            <a:endParaRPr/>
           </a:p>
         </p:txBody>
       </p:sp>
@@ -12339,7 +13094,7 @@
 </file>
 
 <file path=ppt/slides/slide28.xml><?xml version="1.0" encoding="utf-8"?>
-<p:sld xmlns:a="http://schemas.openxmlformats.org/drawingml/2006/main" xmlns:p="http://schemas.openxmlformats.org/presentationml/2006/main" xmlns:r="http://schemas.openxmlformats.org/officeDocument/2006/relationships">
+<p:sld xmlns:a="http://schemas.openxmlformats.org/drawingml/2006/main" xmlns:r="http://schemas.openxmlformats.org/officeDocument/2006/relationships" xmlns:p="http://schemas.openxmlformats.org/presentationml/2006/main">
   <p:cSld>
     <p:bg>
       <p:bgPr>
@@ -12355,7 +13110,14 @@
         <p:cNvGrpSpPr/>
         <p:nvPr/>
       </p:nvGrpSpPr>
-      <p:grpSpPr/>
+      <p:grpSpPr>
+        <a:xfrm>
+          <a:off x="0" y="0"/>
+          <a:ext cx="0" cy="0"/>
+          <a:chOff x="0" y="0"/>
+          <a:chExt cx="0" cy="0"/>
+        </a:xfrm>
+      </p:grpSpPr>
       <p:sp>
         <p:nvSpPr>
           <p:cNvPr id="2" name="TextBox 1"/>
@@ -12516,6 +13278,7 @@
           <a:lstStyle/>
           <a:p>
             <a:pPr algn="ctr"/>
+            <a:endParaRPr/>
           </a:p>
         </p:txBody>
       </p:sp>
@@ -12640,6 +13403,7 @@
           <a:lstStyle/>
           <a:p>
             <a:pPr algn="ctr"/>
+            <a:endParaRPr/>
           </a:p>
         </p:txBody>
       </p:sp>
@@ -12764,6 +13528,7 @@
           <a:lstStyle/>
           <a:p>
             <a:pPr algn="ctr"/>
+            <a:endParaRPr/>
           </a:p>
         </p:txBody>
       </p:sp>
@@ -12971,7 +13736,7 @@
 </file>
 
 <file path=ppt/slides/slide29.xml><?xml version="1.0" encoding="utf-8"?>
-<p:sld xmlns:a="http://schemas.openxmlformats.org/drawingml/2006/main" xmlns:p="http://schemas.openxmlformats.org/presentationml/2006/main" xmlns:r="http://schemas.openxmlformats.org/officeDocument/2006/relationships">
+<p:sld xmlns:a="http://schemas.openxmlformats.org/drawingml/2006/main" xmlns:r="http://schemas.openxmlformats.org/officeDocument/2006/relationships" xmlns:p="http://schemas.openxmlformats.org/presentationml/2006/main">
   <p:cSld>
     <p:bg>
       <p:bgPr>
@@ -12987,7 +13752,14 @@
         <p:cNvGrpSpPr/>
         <p:nvPr/>
       </p:nvGrpSpPr>
-      <p:grpSpPr/>
+      <p:grpSpPr>
+        <a:xfrm>
+          <a:off x="0" y="0"/>
+          <a:ext cx="0" cy="0"/>
+          <a:chOff x="0" y="0"/>
+          <a:chExt cx="0" cy="0"/>
+        </a:xfrm>
+      </p:grpSpPr>
       <p:sp>
         <p:nvSpPr>
           <p:cNvPr id="2" name="TextBox 1"/>
@@ -13189,6 +13961,7 @@
           <a:lstStyle/>
           <a:p>
             <a:pPr algn="ctr"/>
+            <a:endParaRPr/>
           </a:p>
         </p:txBody>
       </p:sp>
@@ -13313,6 +14086,7 @@
           <a:lstStyle/>
           <a:p>
             <a:pPr algn="ctr"/>
+            <a:endParaRPr/>
           </a:p>
         </p:txBody>
       </p:sp>
@@ -13481,7 +14255,7 @@
 </file>
 
 <file path=ppt/slides/slide3.xml><?xml version="1.0" encoding="utf-8"?>
-<p:sld xmlns:a="http://schemas.openxmlformats.org/drawingml/2006/main" xmlns:p="http://schemas.openxmlformats.org/presentationml/2006/main" xmlns:r="http://schemas.openxmlformats.org/officeDocument/2006/relationships">
+<p:sld xmlns:a="http://schemas.openxmlformats.org/drawingml/2006/main" xmlns:r="http://schemas.openxmlformats.org/officeDocument/2006/relationships" xmlns:p="http://schemas.openxmlformats.org/presentationml/2006/main">
   <p:cSld>
     <p:bg>
       <p:bgPr>
@@ -13497,7 +14271,14 @@
         <p:cNvGrpSpPr/>
         <p:nvPr/>
       </p:nvGrpSpPr>
-      <p:grpSpPr/>
+      <p:grpSpPr>
+        <a:xfrm>
+          <a:off x="0" y="0"/>
+          <a:ext cx="0" cy="0"/>
+          <a:chOff x="0" y="0"/>
+          <a:chExt cx="0" cy="0"/>
+        </a:xfrm>
+      </p:grpSpPr>
       <p:sp>
         <p:nvSpPr>
           <p:cNvPr id="2" name="TextBox 1"/>
@@ -13619,6 +14400,7 @@
           <a:lstStyle/>
           <a:p>
             <a:pPr algn="ctr"/>
+            <a:endParaRPr/>
           </a:p>
         </p:txBody>
       </p:sp>
@@ -13743,6 +14525,7 @@
           <a:lstStyle/>
           <a:p>
             <a:pPr algn="ctr"/>
+            <a:endParaRPr/>
           </a:p>
         </p:txBody>
       </p:sp>
@@ -13867,6 +14650,7 @@
           <a:lstStyle/>
           <a:p>
             <a:pPr algn="ctr"/>
+            <a:endParaRPr/>
           </a:p>
         </p:txBody>
       </p:sp>
@@ -14074,7 +14858,7 @@
 </file>
 
 <file path=ppt/slides/slide30.xml><?xml version="1.0" encoding="utf-8"?>
-<p:sld xmlns:a="http://schemas.openxmlformats.org/drawingml/2006/main" xmlns:p="http://schemas.openxmlformats.org/presentationml/2006/main" xmlns:r="http://schemas.openxmlformats.org/officeDocument/2006/relationships">
+<p:sld xmlns:a="http://schemas.openxmlformats.org/drawingml/2006/main" xmlns:r="http://schemas.openxmlformats.org/officeDocument/2006/relationships" xmlns:p="http://schemas.openxmlformats.org/presentationml/2006/main">
   <p:cSld>
     <p:bg>
       <p:bgPr>
@@ -14090,7 +14874,14 @@
         <p:cNvGrpSpPr/>
         <p:nvPr/>
       </p:nvGrpSpPr>
-      <p:grpSpPr/>
+      <p:grpSpPr>
+        <a:xfrm>
+          <a:off x="0" y="0"/>
+          <a:ext cx="0" cy="0"/>
+          <a:chOff x="0" y="0"/>
+          <a:chExt cx="0" cy="0"/>
+        </a:xfrm>
+      </p:grpSpPr>
       <p:sp>
         <p:nvSpPr>
           <p:cNvPr id="2" name="TextBox 1"/>
@@ -14177,8 +14968,8 @@
         </p:nvSpPr>
         <p:spPr>
           <a:xfrm>
-            <a:off x="777240" y="2743200"/>
-            <a:ext cx="7040880" cy="1645920"/>
+            <a:off x="708660" y="2314920"/>
+            <a:ext cx="7040880" cy="2627194"/>
           </a:xfrm>
           <a:prstGeom prst="rect">
             <a:avLst/>
@@ -14197,14 +14988,173 @@
               </a:lnSpc>
             </a:pPr>
             <a:r>
-              <a:rPr sz="1600" b="0" i="0">
+              <a:rPr sz="1600" b="0" i="0" dirty="0">
                 <a:solidFill>
                   <a:srgbClr val="E3DFD6"/>
                 </a:solidFill>
                 <a:latin typeface="Calibri"/>
               </a:rPr>
-              <a:t>Marc Pierson developed the eleven steps and published them as Systems Certification. They were used with a cohort of students who had left school. One of them did it first. Then the cohort's facilitator did it, then her administrator, each alone at the same table — and then four more students at once.</a:t>
-            </a:r>
+              <a:t>Marc Pierson developed the eleven steps </a:t>
+            </a:r>
+            <a:r>
+              <a:rPr lang="en-US" sz="1600" b="0" i="0" dirty="0">
+                <a:solidFill>
+                  <a:srgbClr val="E3DFD6"/>
+                </a:solidFill>
+                <a:latin typeface="Calibri"/>
+              </a:rPr>
+              <a:t>to test his hypotheses that everyone is already an expert systems thinker</a:t>
+            </a:r>
+            <a:r>
+              <a:rPr sz="1600" b="0" i="0" dirty="0">
+                <a:solidFill>
+                  <a:srgbClr val="E3DFD6"/>
+                </a:solidFill>
+                <a:latin typeface="Calibri"/>
+              </a:rPr>
+              <a:t>. They were used with </a:t>
+            </a:r>
+            <a:r>
+              <a:rPr lang="en-US" sz="1600" b="0" i="0" dirty="0">
+                <a:solidFill>
+                  <a:srgbClr val="E3DFD6"/>
+                </a:solidFill>
+                <a:latin typeface="Calibri"/>
+              </a:rPr>
+              <a:t>a series of people at his kitchen table and then </a:t>
+            </a:r>
+            <a:r>
+              <a:rPr sz="1600" b="0" i="0" dirty="0">
+                <a:solidFill>
+                  <a:srgbClr val="E3DFD6"/>
+                </a:solidFill>
+                <a:latin typeface="Calibri"/>
+              </a:rPr>
+              <a:t>a cohort of </a:t>
+            </a:r>
+            <a:r>
+              <a:rPr lang="en-US" sz="1600" b="0" i="0" dirty="0">
+                <a:solidFill>
+                  <a:srgbClr val="E3DFD6"/>
+                </a:solidFill>
+                <a:latin typeface="Calibri"/>
+              </a:rPr>
+              <a:t>five </a:t>
+            </a:r>
+            <a:r>
+              <a:rPr sz="1600" b="0" i="0" dirty="0">
+                <a:solidFill>
+                  <a:srgbClr val="E3DFD6"/>
+                </a:solidFill>
+                <a:latin typeface="Calibri"/>
+              </a:rPr>
+              <a:t>students who had left </a:t>
+            </a:r>
+            <a:r>
+              <a:rPr lang="en-US" sz="1600" b="0" i="0" dirty="0">
+                <a:solidFill>
+                  <a:srgbClr val="E3DFD6"/>
+                </a:solidFill>
+                <a:latin typeface="Calibri"/>
+              </a:rPr>
+              <a:t>high </a:t>
+            </a:r>
+            <a:r>
+              <a:rPr sz="1600" b="0" i="0" dirty="0">
+                <a:solidFill>
+                  <a:srgbClr val="E3DFD6"/>
+                </a:solidFill>
+                <a:latin typeface="Calibri"/>
+              </a:rPr>
+              <a:t>school. One of </a:t>
+            </a:r>
+            <a:r>
+              <a:rPr lang="en-US" sz="1600" b="0" i="0" dirty="0">
+                <a:solidFill>
+                  <a:srgbClr val="E3DFD6"/>
+                </a:solidFill>
+                <a:latin typeface="Calibri"/>
+              </a:rPr>
+              <a:t>the disaffected students</a:t>
+            </a:r>
+            <a:r>
+              <a:rPr sz="1600" b="0" i="0" dirty="0">
+                <a:solidFill>
+                  <a:srgbClr val="E3DFD6"/>
+                </a:solidFill>
+                <a:latin typeface="Calibri"/>
+              </a:rPr>
+              <a:t> did it first. Then the cohort's facilitator did it, then her administrator, each alone at the same </a:t>
+            </a:r>
+            <a:r>
+              <a:rPr lang="en-US" sz="1600" b="0" i="0" dirty="0">
+                <a:solidFill>
+                  <a:srgbClr val="E3DFD6"/>
+                </a:solidFill>
+                <a:latin typeface="Calibri"/>
+              </a:rPr>
+              <a:t>kitchen </a:t>
+            </a:r>
+            <a:r>
+              <a:rPr sz="1600" b="0" i="0" dirty="0">
+                <a:solidFill>
+                  <a:srgbClr val="E3DFD6"/>
+                </a:solidFill>
+                <a:latin typeface="Calibri"/>
+              </a:rPr>
+              <a:t>table — and then </a:t>
+            </a:r>
+            <a:r>
+              <a:rPr lang="en-US" sz="1600" b="0" i="0" dirty="0">
+                <a:solidFill>
+                  <a:srgbClr val="E3DFD6"/>
+                </a:solidFill>
+                <a:latin typeface="Calibri"/>
+              </a:rPr>
+              <a:t>five </a:t>
+            </a:r>
+            <a:r>
+              <a:rPr sz="1600" b="0" i="0" dirty="0">
+                <a:solidFill>
+                  <a:srgbClr val="E3DFD6"/>
+                </a:solidFill>
+                <a:latin typeface="Calibri"/>
+              </a:rPr>
+              <a:t>students at once</a:t>
+            </a:r>
+            <a:r>
+              <a:rPr lang="en-US" sz="1600" b="0" i="0" dirty="0">
+                <a:solidFill>
+                  <a:srgbClr val="E3DFD6"/>
+                </a:solidFill>
+                <a:latin typeface="Calibri"/>
+              </a:rPr>
+              <a:t>—independently . </a:t>
+            </a:r>
+            <a:r>
+              <a:rPr lang="en-US" sz="1600" dirty="0">
+                <a:solidFill>
+                  <a:srgbClr val="E3DFD6"/>
+                </a:solidFill>
+                <a:latin typeface="Calibri"/>
+              </a:rPr>
+              <a:t>T</a:t>
+            </a:r>
+            <a:r>
+              <a:rPr lang="en-US" sz="1600" b="0" i="0" dirty="0">
+                <a:solidFill>
+                  <a:srgbClr val="E3DFD6"/>
+                </a:solidFill>
+                <a:latin typeface="Calibri"/>
+              </a:rPr>
+              <a:t>hen they spent six weeks consolidating their work. The students were the only ones give a prompt: What would you like to learn between now and when you are the head of a household?</a:t>
+            </a:r>
+            <a:endParaRPr sz="1600" b="0" i="0" dirty="0">
+              <a:solidFill>
+                <a:srgbClr val="E3DFD6"/>
+              </a:solidFill>
+              <a:latin typeface="Calibri"/>
+            </a:endParaRPr>
           </a:p>
         </p:txBody>
       </p:sp>
@@ -14216,7 +15166,7 @@
         </p:nvSpPr>
         <p:spPr>
           <a:xfrm>
-            <a:off x="777240" y="4526280"/>
+            <a:off x="777240" y="5029200"/>
             <a:ext cx="7040880" cy="1005840"/>
           </a:xfrm>
           <a:prstGeom prst="rect">
@@ -14236,7 +15186,7 @@
               </a:lnSpc>
             </a:pPr>
             <a:r>
-              <a:rPr sz="1500" b="0" i="1">
+              <a:rPr sz="1500" b="0" i="1" dirty="0">
                 <a:solidFill>
                   <a:srgbClr val="A8A296"/>
                 </a:solidFill>
@@ -14288,6 +15238,7 @@
           <a:lstStyle/>
           <a:p>
             <a:pPr algn="ctr"/>
+            <a:endParaRPr/>
           </a:p>
         </p:txBody>
       </p:sp>
@@ -14300,7 +15251,7 @@
         <p:spPr>
           <a:xfrm>
             <a:off x="8503920" y="3017520"/>
-            <a:ext cx="2651760" cy="2377440"/>
+            <a:ext cx="2651760" cy="2099421"/>
           </a:xfrm>
           <a:prstGeom prst="rect">
             <a:avLst/>
@@ -14319,19 +15270,140 @@
               </a:lnSpc>
             </a:pPr>
             <a:r>
-              <a:rPr sz="1450" b="0" i="0">
+              <a:rPr sz="1450" b="0" i="0" dirty="0">
                 <a:solidFill>
                   <a:srgbClr val="FFFFFF"/>
                 </a:solidFill>
                 <a:latin typeface="Calibri"/>
               </a:rPr>
-              <a:t>The reflection steps
-were not in the first
-version.
-They were added
-because the fear was
-visible and needed
-somewhere to go.</a:t>
+              <a:t>The reflection steps</a:t>
+            </a:r>
+            <a:r>
+              <a:rPr lang="en-US" sz="1450" b="0" i="0" dirty="0">
+                <a:solidFill>
+                  <a:srgbClr val="FFFFFF"/>
+                </a:solidFill>
+                <a:latin typeface="Calibri"/>
+              </a:rPr>
+              <a:t> </a:t>
+            </a:r>
+            <a:r>
+              <a:rPr sz="1450" b="0" i="0" dirty="0">
+                <a:solidFill>
+                  <a:srgbClr val="FFFFFF"/>
+                </a:solidFill>
+                <a:latin typeface="Calibri"/>
+              </a:rPr>
+              <a:t>were not in the first</a:t>
+            </a:r>
+            <a:r>
+              <a:rPr lang="en-US" sz="1450" b="0" i="0" dirty="0">
+                <a:solidFill>
+                  <a:srgbClr val="FFFFFF"/>
+                </a:solidFill>
+                <a:latin typeface="Calibri"/>
+              </a:rPr>
+              <a:t> </a:t>
+            </a:r>
+            <a:r>
+              <a:rPr sz="1450" b="0" i="0" dirty="0">
+                <a:solidFill>
+                  <a:srgbClr val="FFFFFF"/>
+                </a:solidFill>
+                <a:latin typeface="Calibri"/>
+              </a:rPr>
+              <a:t>version.
+They were added</a:t>
+            </a:r>
+            <a:r>
+              <a:rPr lang="en-US" sz="1450" b="0" i="0" dirty="0">
+                <a:solidFill>
+                  <a:srgbClr val="FFFFFF"/>
+                </a:solidFill>
+                <a:latin typeface="Calibri"/>
+              </a:rPr>
+              <a:t> </a:t>
+            </a:r>
+            <a:r>
+              <a:rPr sz="1450" b="0" i="0" dirty="0">
+                <a:solidFill>
+                  <a:srgbClr val="FFFFFF"/>
+                </a:solidFill>
+                <a:latin typeface="Calibri"/>
+              </a:rPr>
+              <a:t>because the fear was</a:t>
+            </a:r>
+            <a:r>
+              <a:rPr lang="en-US" sz="1450" dirty="0">
+                <a:solidFill>
+                  <a:srgbClr val="FFFFFF"/>
+                </a:solidFill>
+                <a:latin typeface="Calibri"/>
+              </a:rPr>
+              <a:t> frequently </a:t>
+            </a:r>
+            <a:r>
+              <a:rPr sz="1450" b="0" i="0" dirty="0">
+                <a:solidFill>
+                  <a:srgbClr val="FFFFFF"/>
+                </a:solidFill>
+                <a:latin typeface="Calibri"/>
+              </a:rPr>
+              <a:t>visible and</a:t>
+            </a:r>
+            <a:r>
+              <a:rPr lang="en-US" sz="1450" dirty="0">
+                <a:solidFill>
+                  <a:srgbClr val="FFFFFF"/>
+                </a:solidFill>
+                <a:latin typeface="Calibri"/>
+              </a:rPr>
+              <a:t> exploring that</a:t>
+            </a:r>
+            <a:r>
+              <a:rPr sz="1450" b="0" i="0" dirty="0">
+                <a:solidFill>
+                  <a:srgbClr val="FFFFFF"/>
+                </a:solidFill>
+                <a:latin typeface="Calibri"/>
+              </a:rPr>
+              <a:t> </a:t>
+            </a:r>
+            <a:r>
+              <a:rPr lang="en-US" sz="1450" b="0" i="0" dirty="0">
+                <a:solidFill>
+                  <a:srgbClr val="FFFFFF"/>
+                </a:solidFill>
+                <a:latin typeface="Calibri"/>
+              </a:rPr>
+              <a:t>offered perhaps</a:t>
+            </a:r>
+            <a:r>
+              <a:rPr lang="en-US" sz="1450" dirty="0">
+                <a:solidFill>
+                  <a:srgbClr val="FFFFFF"/>
+                </a:solidFill>
+                <a:latin typeface="Calibri"/>
+              </a:rPr>
+              <a:t> </a:t>
+            </a:r>
+            <a:r>
+              <a:rPr lang="en-US" sz="1450" b="0" i="0" dirty="0">
+                <a:solidFill>
+                  <a:srgbClr val="FFFFFF"/>
+                </a:solidFill>
+                <a:latin typeface="Calibri"/>
+              </a:rPr>
+              <a:t>the most important learning</a:t>
+            </a:r>
+            <a:r>
+              <a:rPr sz="1450" b="0" i="0" dirty="0">
+                <a:solidFill>
+                  <a:srgbClr val="FFFFFF"/>
+                </a:solidFill>
+                <a:latin typeface="Calibri"/>
+              </a:rPr>
+              <a:t>.</a:t>
             </a:r>
           </a:p>
         </p:txBody>
@@ -14377,6 +15449,7 @@
           <a:lstStyle/>
           <a:p>
             <a:pPr algn="ctr"/>
+            <a:endParaRPr/>
           </a:p>
         </p:txBody>
       </p:sp>
@@ -14506,7 +15579,7 @@
 </file>
 
 <file path=ppt/slides/slide4.xml><?xml version="1.0" encoding="utf-8"?>
-<p:sld xmlns:a="http://schemas.openxmlformats.org/drawingml/2006/main" xmlns:p="http://schemas.openxmlformats.org/presentationml/2006/main" xmlns:r="http://schemas.openxmlformats.org/officeDocument/2006/relationships">
+<p:sld xmlns:a="http://schemas.openxmlformats.org/drawingml/2006/main" xmlns:r="http://schemas.openxmlformats.org/officeDocument/2006/relationships" xmlns:p="http://schemas.openxmlformats.org/presentationml/2006/main">
   <p:cSld>
     <p:bg>
       <p:bgPr>
@@ -14522,7 +15595,14 @@
         <p:cNvGrpSpPr/>
         <p:nvPr/>
       </p:nvGrpSpPr>
-      <p:grpSpPr/>
+      <p:grpSpPr>
+        <a:xfrm>
+          <a:off x="0" y="0"/>
+          <a:ext cx="0" cy="0"/>
+          <a:chOff x="0" y="0"/>
+          <a:chExt cx="0" cy="0"/>
+        </a:xfrm>
+      </p:grpSpPr>
       <p:sp>
         <p:nvSpPr>
           <p:cNvPr id="2" name="TextBox 1"/>
@@ -14644,6 +15724,7 @@
           <a:lstStyle/>
           <a:p>
             <a:pPr algn="ctr"/>
+            <a:endParaRPr/>
           </a:p>
         </p:txBody>
       </p:sp>
@@ -14807,6 +15888,7 @@
           <a:lstStyle/>
           <a:p>
             <a:pPr algn="ctr"/>
+            <a:endParaRPr/>
           </a:p>
         </p:txBody>
       </p:sp>
@@ -14970,6 +16052,7 @@
           <a:lstStyle/>
           <a:p>
             <a:pPr algn="ctr"/>
+            <a:endParaRPr/>
           </a:p>
         </p:txBody>
       </p:sp>
@@ -15131,6 +16214,7 @@
           <a:lstStyle/>
           <a:p>
             <a:pPr algn="ctr"/>
+            <a:endParaRPr/>
           </a:p>
         </p:txBody>
       </p:sp>
@@ -15221,7 +16305,7 @@
 </file>
 
 <file path=ppt/slides/slide5.xml><?xml version="1.0" encoding="utf-8"?>
-<p:sld xmlns:a="http://schemas.openxmlformats.org/drawingml/2006/main" xmlns:p="http://schemas.openxmlformats.org/presentationml/2006/main" xmlns:r="http://schemas.openxmlformats.org/officeDocument/2006/relationships">
+<p:sld xmlns:a="http://schemas.openxmlformats.org/drawingml/2006/main" xmlns:r="http://schemas.openxmlformats.org/officeDocument/2006/relationships" xmlns:p="http://schemas.openxmlformats.org/presentationml/2006/main">
   <p:cSld>
     <p:bg>
       <p:bgPr>
@@ -15237,7 +16321,14 @@
         <p:cNvGrpSpPr/>
         <p:nvPr/>
       </p:nvGrpSpPr>
-      <p:grpSpPr/>
+      <p:grpSpPr>
+        <a:xfrm>
+          <a:off x="0" y="0"/>
+          <a:ext cx="0" cy="0"/>
+          <a:chOff x="0" y="0"/>
+          <a:chExt cx="0" cy="0"/>
+        </a:xfrm>
+      </p:grpSpPr>
       <p:sp>
         <p:nvSpPr>
           <p:cNvPr id="2" name="TextBox 1"/>
@@ -15436,6 +16527,7 @@
           <a:lstStyle/>
           <a:p>
             <a:pPr algn="ctr"/>
+            <a:endParaRPr/>
           </a:p>
         </p:txBody>
       </p:sp>
@@ -15447,8 +16539,8 @@
         </p:nvSpPr>
         <p:spPr>
           <a:xfrm>
-            <a:off x="9052560" y="2194560"/>
-            <a:ext cx="2194560" cy="3017520"/>
+            <a:off x="8823960" y="1929157"/>
+            <a:ext cx="2606040" cy="2679644"/>
           </a:xfrm>
           <a:prstGeom prst="rect">
             <a:avLst/>
@@ -15467,7 +16559,7 @@
               </a:lnSpc>
             </a:pPr>
             <a:r>
-              <a:rPr sz="1450" b="0" i="0">
+              <a:rPr sz="1450" b="0" i="0" dirty="0">
                 <a:solidFill>
                   <a:srgbClr val="FFFFFF"/>
                 </a:solidFill>
@@ -15572,7 +16664,7 @@
 </file>
 
 <file path=ppt/slides/slide6.xml><?xml version="1.0" encoding="utf-8"?>
-<p:sld xmlns:a="http://schemas.openxmlformats.org/drawingml/2006/main" xmlns:p="http://schemas.openxmlformats.org/presentationml/2006/main" xmlns:r="http://schemas.openxmlformats.org/officeDocument/2006/relationships">
+<p:sld xmlns:a="http://schemas.openxmlformats.org/drawingml/2006/main" xmlns:r="http://schemas.openxmlformats.org/officeDocument/2006/relationships" xmlns:p="http://schemas.openxmlformats.org/presentationml/2006/main">
   <p:cSld>
     <p:bg>
       <p:bgPr>
@@ -15588,7 +16680,14 @@
         <p:cNvGrpSpPr/>
         <p:nvPr/>
       </p:nvGrpSpPr>
-      <p:grpSpPr/>
+      <p:grpSpPr>
+        <a:xfrm>
+          <a:off x="0" y="0"/>
+          <a:ext cx="0" cy="0"/>
+          <a:chOff x="0" y="0"/>
+          <a:chExt cx="0" cy="0"/>
+        </a:xfrm>
+      </p:grpSpPr>
       <p:sp>
         <p:nvSpPr>
           <p:cNvPr id="2" name="TextBox 1"/>
@@ -15754,7 +16853,7 @@
 </file>
 
 <file path=ppt/slides/slide7.xml><?xml version="1.0" encoding="utf-8"?>
-<p:sld xmlns:a="http://schemas.openxmlformats.org/drawingml/2006/main" xmlns:p="http://schemas.openxmlformats.org/presentationml/2006/main" xmlns:r="http://schemas.openxmlformats.org/officeDocument/2006/relationships">
+<p:sld xmlns:a="http://schemas.openxmlformats.org/drawingml/2006/main" xmlns:r="http://schemas.openxmlformats.org/officeDocument/2006/relationships" xmlns:p="http://schemas.openxmlformats.org/presentationml/2006/main">
   <p:cSld>
     <p:bg>
       <p:bgPr>
@@ -15770,7 +16869,14 @@
         <p:cNvGrpSpPr/>
         <p:nvPr/>
       </p:nvGrpSpPr>
-      <p:grpSpPr/>
+      <p:grpSpPr>
+        <a:xfrm>
+          <a:off x="0" y="0"/>
+          <a:ext cx="0" cy="0"/>
+          <a:chOff x="0" y="0"/>
+          <a:chExt cx="0" cy="0"/>
+        </a:xfrm>
+      </p:grpSpPr>
       <p:sp>
         <p:nvSpPr>
           <p:cNvPr id="2" name="TextBox 1"/>
@@ -16015,7 +17121,7 @@
 </file>
 
 <file path=ppt/slides/slide8.xml><?xml version="1.0" encoding="utf-8"?>
-<p:sld xmlns:a="http://schemas.openxmlformats.org/drawingml/2006/main" xmlns:p="http://schemas.openxmlformats.org/presentationml/2006/main" xmlns:r="http://schemas.openxmlformats.org/officeDocument/2006/relationships">
+<p:sld xmlns:a="http://schemas.openxmlformats.org/drawingml/2006/main" xmlns:r="http://schemas.openxmlformats.org/officeDocument/2006/relationships" xmlns:p="http://schemas.openxmlformats.org/presentationml/2006/main">
   <p:cSld>
     <p:bg>
       <p:bgPr>
@@ -16031,7 +17137,14 @@
         <p:cNvGrpSpPr/>
         <p:nvPr/>
       </p:nvGrpSpPr>
-      <p:grpSpPr/>
+      <p:grpSpPr>
+        <a:xfrm>
+          <a:off x="0" y="0"/>
+          <a:ext cx="0" cy="0"/>
+          <a:chOff x="0" y="0"/>
+          <a:chExt cx="0" cy="0"/>
+        </a:xfrm>
+      </p:grpSpPr>
       <p:sp>
         <p:nvSpPr>
           <p:cNvPr id="2" name="TextBox 1"/>
@@ -16277,7 +17390,7 @@
 </file>
 
 <file path=ppt/slides/slide9.xml><?xml version="1.0" encoding="utf-8"?>
-<p:sld xmlns:a="http://schemas.openxmlformats.org/drawingml/2006/main" xmlns:p="http://schemas.openxmlformats.org/presentationml/2006/main" xmlns:r="http://schemas.openxmlformats.org/officeDocument/2006/relationships">
+<p:sld xmlns:a="http://schemas.openxmlformats.org/drawingml/2006/main" xmlns:r="http://schemas.openxmlformats.org/officeDocument/2006/relationships" xmlns:p="http://schemas.openxmlformats.org/presentationml/2006/main">
   <p:cSld>
     <p:bg>
       <p:bgPr>
@@ -16293,7 +17406,14 @@
         <p:cNvGrpSpPr/>
         <p:nvPr/>
       </p:nvGrpSpPr>
-      <p:grpSpPr/>
+      <p:grpSpPr>
+        <a:xfrm>
+          <a:off x="0" y="0"/>
+          <a:ext cx="0" cy="0"/>
+          <a:chOff x="0" y="0"/>
+          <a:chExt cx="0" cy="0"/>
+        </a:xfrm>
+      </p:grpSpPr>
       <p:sp>
         <p:nvSpPr>
           <p:cNvPr id="2" name="TextBox 1"/>

</xml_diff>